<commit_message>
docs(deck): commit the rebuild that the previous commit left behind
The generator changes of 2163dfb were committed without the regenerated
file, so the deck on disk and the deck in the repository had diverged.
</commit_message>
<xml_diff>
--- a/docs/valletta_model_concept_2026-09-25.pptx
+++ b/docs/valletta_model_concept_2026-09-25.pptx
@@ -4,6 +4,9 @@
   <p:sldMasterIdLst>
     <p:sldMasterId id="2147483648" r:id="rId1"/>
   </p:sldMasterIdLst>
+  <p:notesMasterIdLst>
+    <p:notesMasterId r:id="rId13"/>
+  </p:notesMasterIdLst>
   <p:sldIdLst>
     <p:sldId id="256" r:id="rId2"/>
     <p:sldId id="257" r:id="rId3"/>
@@ -17,9 +20,6 @@
     <p:sldId id="265" r:id="rId11"/>
     <p:sldId id="266" r:id="rId12"/>
   </p:sldIdLst>
-  <p:notesMasterIdLst>
-    <p:notesMasterId r:id="rId13"/>
-  </p:notesMasterIdLst>
   <p:sldSz cx="12192000" cy="6858000"/>
   <p:notesSz cx="6858000" cy="12192000"/>
   <p:defaultTextStyle>
@@ -114,6 +114,11 @@
       </a:defRPr>
     </a:lvl9pPr>
   </p:defaultTextStyle>
+  <p:extLst>
+    <p:ext uri="{EFAFB233-063F-42B5-8137-9DF3F51BA10A}">
+      <p15:sldGuideLst xmlns:p15="http://schemas.microsoft.com/office/powerpoint/2012/main"/>
+    </p:ext>
+  </p:extLst>
 </p:presentation>
 </file>
 
@@ -139,234 +144,10 @@
           <a:chExt cx="0" cy="0"/>
         </a:xfrm>
       </p:grpSpPr>
-      <p:sp>
-        <p:nvSpPr>
-          <p:cNvPr id="2" name="Header Placeholder 1"/>
-          <p:cNvSpPr>
-            <a:spLocks noGrp="1"/>
-          </p:cNvSpPr>
-          <p:nvPr>
-            <p:ph type="hdr" sz="quarter"/>
-          </p:nvPr>
-        </p:nvSpPr>
-        <p:spPr>
-          <a:xfrm>
-            <a:off x="0" y="0"/>
-            <a:ext cx="2971800" cy="458788"/>
-          </a:xfrm>
-          <a:prstGeom prst="rect">
-            <a:avLst/>
-          </a:prstGeom>
-        </p:spPr>
-        <p:txBody>
-          <a:bodyPr vert="horz" lIns="91440" tIns="45720" rIns="91440" bIns="45720" rtlCol="0"/>
-          <a:lstStyle>
-            <a:lvl1pPr algn="l">
-              <a:defRPr sz="1200"/>
-            </a:lvl1pPr>
-          </a:lstStyle>
-          <a:p>
-            <a:endParaRPr lang="en-US"/>
-          </a:p>
-        </p:txBody>
-      </p:sp>
-      <p:sp>
-        <p:nvSpPr>
-          <p:cNvPr id="3" name="Date Placeholder 2"/>
-          <p:cNvSpPr>
-            <a:spLocks noGrp="1"/>
-          </p:cNvSpPr>
-          <p:nvPr>
-            <p:ph type="dt" idx="1"/>
-          </p:nvPr>
-        </p:nvSpPr>
-        <p:spPr>
-          <a:xfrm>
-            <a:off x="3884613" y="0"/>
-            <a:ext cx="2971800" cy="458788"/>
-          </a:xfrm>
-          <a:prstGeom prst="rect">
-            <a:avLst/>
-          </a:prstGeom>
-        </p:spPr>
-        <p:txBody>
-          <a:bodyPr vert="horz" lIns="91440" tIns="45720" rIns="91440" bIns="45720" rtlCol="0"/>
-          <a:lstStyle>
-            <a:lvl1pPr algn="r">
-              <a:defRPr sz="1200"/>
-            </a:lvl1pPr>
-          </a:lstStyle>
-          <a:p>
-            <a:fld id="{5282F153-3F37-0F45-9E97-73ACFA13230C}" type="datetimeFigureOut">
-              <a:rPr lang="en-US"/>
-              <a:t>7/23/19</a:t>
-            </a:fld>
-            <a:endParaRPr lang="en-US"/>
-          </a:p>
-        </p:txBody>
-      </p:sp>
-      <p:sp>
-        <p:nvSpPr>
-          <p:cNvPr id="4" name="Slide Image Placeholder 3"/>
-          <p:cNvSpPr>
-            <a:spLocks noGrp="1" noRot="1" noChangeAspect="1"/>
-          </p:cNvSpPr>
-          <p:nvPr>
-            <p:ph type="sldImg" idx="2"/>
-          </p:nvPr>
-        </p:nvSpPr>
-        <p:spPr>
-          <a:xfrm>
-            <a:off x="685800" y="1143000"/>
-            <a:ext cx="5486400" cy="3086100"/>
-          </a:xfrm>
-          <a:prstGeom prst="rect">
-            <a:avLst/>
-          </a:prstGeom>
-          <a:noFill/>
-          <a:ln w="12700">
-            <a:solidFill>
-              <a:prstClr val="black"/>
-            </a:solidFill>
-          </a:ln>
-        </p:spPr>
-        <p:txBody>
-          <a:bodyPr vert="horz" lIns="91440" tIns="45720" rIns="91440" bIns="45720" rtlCol="0" anchor="ctr"/>
-          <a:lstStyle/>
-          <a:p>
-            <a:endParaRPr lang="en-US"/>
-          </a:p>
-        </p:txBody>
-      </p:sp>
-      <p:sp>
-        <p:nvSpPr>
-          <p:cNvPr id="5" name="Notes Placeholder 4"/>
-          <p:cNvSpPr>
-            <a:spLocks noGrp="1"/>
-          </p:cNvSpPr>
-          <p:nvPr>
-            <p:ph type="body" sz="quarter" idx="3"/>
-          </p:nvPr>
-        </p:nvSpPr>
-        <p:spPr>
-          <a:xfrm>
-            <a:off x="685800" y="4400550"/>
-            <a:ext cx="5486400" cy="3600450"/>
-          </a:xfrm>
-          <a:prstGeom prst="rect">
-            <a:avLst/>
-          </a:prstGeom>
-        </p:spPr>
-        <p:txBody>
-          <a:bodyPr vert="horz" lIns="91440" tIns="45720" rIns="91440" bIns="45720" rtlCol="0"/>
-          <a:lstStyle/>
-          <a:p>
-            <a:pPr lvl="0"/>
-            <a:r>
-              <a:rPr lang="en-US"/>
-              <a:t>Click to edit Master text styles</a:t>
-            </a:r>
-          </a:p>
-          <a:p>
-            <a:pPr lvl="1"/>
-            <a:r>
-              <a:rPr lang="en-US"/>
-              <a:t>Second level</a:t>
-            </a:r>
-          </a:p>
-          <a:p>
-            <a:pPr lvl="2"/>
-            <a:r>
-              <a:rPr lang="en-US"/>
-              <a:t>Third level</a:t>
-            </a:r>
-          </a:p>
-          <a:p>
-            <a:pPr lvl="3"/>
-            <a:r>
-              <a:rPr lang="en-US"/>
-              <a:t>Fourth level</a:t>
-            </a:r>
-          </a:p>
-          <a:p>
-            <a:pPr lvl="4"/>
-            <a:r>
-              <a:rPr lang="en-US"/>
-              <a:t>Fifth level</a:t>
-            </a:r>
-          </a:p>
-        </p:txBody>
-      </p:sp>
-      <p:sp>
-        <p:nvSpPr>
-          <p:cNvPr id="6" name="Footer Placeholder 5"/>
-          <p:cNvSpPr>
-            <a:spLocks noGrp="1"/>
-          </p:cNvSpPr>
-          <p:nvPr>
-            <p:ph type="ftr" sz="quarter" idx="4"/>
-          </p:nvPr>
-        </p:nvSpPr>
-        <p:spPr>
-          <a:xfrm>
-            <a:off x="0" y="8685213"/>
-            <a:ext cx="2971800" cy="458787"/>
-          </a:xfrm>
-          <a:prstGeom prst="rect">
-            <a:avLst/>
-          </a:prstGeom>
-        </p:spPr>
-        <p:txBody>
-          <a:bodyPr vert="horz" lIns="91440" tIns="45720" rIns="91440" bIns="45720" rtlCol="0" anchor="b"/>
-          <a:lstStyle>
-            <a:lvl1pPr algn="l">
-              <a:defRPr sz="1200"/>
-            </a:lvl1pPr>
-          </a:lstStyle>
-          <a:p>
-            <a:endParaRPr lang="en-US"/>
-          </a:p>
-        </p:txBody>
-      </p:sp>
-      <p:sp>
-        <p:nvSpPr>
-          <p:cNvPr id="7" name="Slide Number Placeholder 6"/>
-          <p:cNvSpPr>
-            <a:spLocks noGrp="1"/>
-          </p:cNvSpPr>
-          <p:nvPr>
-            <p:ph type="sldNum" sz="quarter" idx="5"/>
-          </p:nvPr>
-        </p:nvSpPr>
-        <p:spPr>
-          <a:xfrm>
-            <a:off x="3884613" y="8685213"/>
-            <a:ext cx="2971800" cy="458787"/>
-          </a:xfrm>
-          <a:prstGeom prst="rect">
-            <a:avLst/>
-          </a:prstGeom>
-        </p:spPr>
-        <p:txBody>
-          <a:bodyPr vert="horz" lIns="91440" tIns="45720" rIns="91440" bIns="45720" rtlCol="0" anchor="b"/>
-          <a:lstStyle>
-            <a:lvl1pPr algn="r">
-              <a:defRPr sz="1200"/>
-            </a:lvl1pPr>
-          </a:lstStyle>
-          <a:p>
-            <a:fld id="{CE5E9CC1-C706-0F49-92D6-E571CC5EEA8F}" type="slidenum">
-              <a:rPr lang="en-US"/>
-              <a:t>‹#›</a:t>
-            </a:fld>
-            <a:endParaRPr lang="en-US"/>
-          </a:p>
-        </p:txBody>
-      </p:sp>
     </p:spTree>
     <p:extLst>
       <p:ext uri="{BB962C8B-B14F-4D97-AF65-F5344CB8AC3E}">
-        <p14:creationId xmlns:p14="http://schemas.microsoft.com/office/powerpoint/2010/main" val="1024086991"/>
+        <p14:creationId xmlns:p14="http://schemas.microsoft.com/office/powerpoint/2010/main" val="2831109433"/>
       </p:ext>
     </p:extLst>
   </p:cSld>
@@ -514,7 +295,6 @@
               <a:rPr lang="en-US" dirty="0"/>
               <a:t>The deck covers the intended model and the matters to be settled before its construction.</a:t>
             </a:r>
-            <a:endParaRPr lang="en-US" dirty="0"/>
           </a:p>
         </p:txBody>
       </p:sp>
@@ -602,7 +382,6 @@
               <a:rPr lang="en-US" dirty="0"/>
               <a:t>These items determine what the study can be, and the remainder is resolvable by execution. The question of whether the group has its own intentions on the generation side belongs with the preceding slide rather than here.</a:t>
             </a:r>
-            <a:endParaRPr lang="en-US" dirty="0"/>
           </a:p>
         </p:txBody>
       </p:sp>
@@ -690,7 +469,6 @@
               <a:rPr lang="en-US" dirty="0"/>
               <a:t>Block B3 loses four working days to Delft and holds fifteen rather than nineteen.</a:t>
             </a:r>
-            <a:endParaRPr lang="en-US" dirty="0"/>
           </a:p>
         </p:txBody>
       </p:sp>
@@ -778,7 +556,6 @@
               <a:rPr lang="en-US" dirty="0"/>
               <a:t>Context. The thesis contribution is framework reusability, and Valletta constitutes the harder test.</a:t>
             </a:r>
-            <a:endParaRPr lang="en-US" dirty="0"/>
           </a:p>
         </p:txBody>
       </p:sp>
@@ -866,7 +643,6 @@
               <a:rPr lang="en-US" dirty="0"/>
               <a:t>The 10 m data came from the group's own contribution to EMODnet. The public product gives the inlets one to three cells.</a:t>
             </a:r>
-            <a:endParaRPr lang="en-US" dirty="0"/>
           </a:p>
         </p:txBody>
       </p:sp>
@@ -954,7 +730,6 @@
               <a:rPr lang="en-US" dirty="0"/>
               <a:t>The three-stage chain organises the study and determines the domain.</a:t>
             </a:r>
-            <a:endParaRPr lang="en-US" dirty="0"/>
           </a:p>
         </p:txBody>
       </p:sp>
@@ -1042,7 +817,6 @@
               <a:rPr lang="en-US" dirty="0"/>
               <a:t>The estimate was tested against its two plausible failures, the Helmholtz idealisation and excitation below resonance. The domain follows from this table. Whether the group's harbour records carry energy near 17 minutes is the first outstanding question.</a:t>
             </a:r>
-            <a:endParaRPr lang="en-US" dirty="0"/>
           </a:p>
         </p:txBody>
       </p:sp>
@@ -1130,7 +904,6 @@
               <a:rPr lang="en-US" dirty="0"/>
               <a:t>Domain B, roughly 86 by 66 km, east to 15 degrees, short of the escarpment. Stopping there is also what keeps sigma layers defensible.</a:t>
             </a:r>
-            <a:endParaRPr lang="en-US" dirty="0"/>
           </a:p>
         </p:txBody>
       </p:sp>
@@ -1218,7 +991,6 @@
               <a:rPr lang="en-US" dirty="0"/>
               <a:t>A question for Deltares concerns whether sigma holds from 15 m to 150 m, or whether a z-sigma hybrid is indicated.</a:t>
             </a:r>
-            <a:endParaRPr lang="en-US" dirty="0"/>
           </a:p>
         </p:txBody>
       </p:sp>
@@ -1306,7 +1078,6 @@
               <a:rPr lang="en-US" dirty="0"/>
               <a:t>The question is a proposal rather than a decision. Whether the group has work of its own planned on the generation side, and how the effort should be divided if so, is worth putting directly. The applied companion is a map of exposure by inlet and quay, and the fallback, with independent value, is harbour renewal under the Water Framework Directive.</a:t>
             </a:r>
-            <a:endParaRPr lang="en-US" dirty="0"/>
           </a:p>
         </p:txBody>
       </p:sp>
@@ -1394,7 +1165,6 @@
               <a:rPr lang="en-US" dirty="0"/>
               <a:t>A sweep of six speeds by eight directions amounts to forty-eight runs, barotropic and uncoupled, and therefore inexpensive.</a:t>
             </a:r>
-            <a:endParaRPr lang="en-US" dirty="0"/>
           </a:p>
         </p:txBody>
       </p:sp>
@@ -1467,6 +1237,11 @@
 <file path=ppt/slideMasters/slideMaster1.xml><?xml version="1.0" encoding="utf-8"?>
 <p:sldMaster xmlns:a="http://schemas.openxmlformats.org/drawingml/2006/main" xmlns:r="http://schemas.openxmlformats.org/officeDocument/2006/relationships" xmlns:p="http://schemas.openxmlformats.org/presentationml/2006/main">
   <p:cSld>
+    <p:bg>
+      <p:bgRef idx="1001">
+        <a:schemeClr val="bg1"/>
+      </p:bgRef>
+    </p:bg>
     <p:spTree>
       <p:nvGrpSpPr>
         <p:cNvPr id="1" name=""/>
@@ -1749,6 +1524,7 @@
         <a:solidFill>
           <a:srgbClr val="21295C"/>
         </a:solidFill>
+        <a:effectLst/>
       </p:bgPr>
     </p:bg>
     <p:spTree>
@@ -1786,6 +1562,13 @@
           </a:solidFill>
           <a:ln/>
         </p:spPr>
+        <p:txBody>
+          <a:bodyPr/>
+          <a:lstStyle/>
+          <a:p>
+            <a:endParaRPr lang="it-IT"/>
+          </a:p>
+        </p:txBody>
       </p:sp>
       <p:sp>
         <p:nvSpPr>
@@ -1808,6 +1591,13 @@
           </a:solidFill>
           <a:ln/>
         </p:spPr>
+        <p:txBody>
+          <a:bodyPr/>
+          <a:lstStyle/>
+          <a:p>
+            <a:endParaRPr lang="it-IT"/>
+          </a:p>
+        </p:txBody>
       </p:sp>
       <p:sp>
         <p:nvSpPr>
@@ -1830,11 +1620,11 @@
           <a:bodyPr wrap="square" lIns="0" tIns="0" rIns="0" bIns="0" rtlCol="0" anchor="ctr"/>
           <a:lstStyle/>
           <a:p>
-            <a:pPr indent="0" marL="0">
+            <a:pPr marL="0" indent="0">
               <a:buNone/>
             </a:pPr>
             <a:r>
-              <a:rPr lang="en-US" sz="1200" b="1" spc="200" kern="0" dirty="0">
+              <a:rPr lang="en-US" sz="1200" b="1" kern="0" spc="200" dirty="0">
                 <a:solidFill>
                   <a:srgbClr val="EB6834"/>
                 </a:solidFill>
@@ -1869,7 +1659,7 @@
           <a:bodyPr wrap="square" lIns="0" tIns="0" rIns="0" bIns="0" rtlCol="0" anchor="ctr"/>
           <a:lstStyle/>
           <a:p>
-            <a:pPr indent="0" marL="0">
+            <a:pPr marL="0" indent="0">
               <a:buNone/>
             </a:pPr>
             <a:r>
@@ -1908,7 +1698,7 @@
           <a:bodyPr wrap="square" lIns="0" tIns="0" rIns="0" bIns="0" rtlCol="0" anchor="ctr"/>
           <a:lstStyle/>
           <a:p>
-            <a:pPr indent="0" marL="0">
+            <a:pPr marL="0" indent="0">
               <a:buNone/>
             </a:pPr>
             <a:r>
@@ -1947,7 +1737,7 @@
           <a:bodyPr wrap="square" lIns="0" tIns="0" rIns="0" bIns="0" rtlCol="0" anchor="ctr"/>
           <a:lstStyle/>
           <a:p>
-            <a:pPr indent="0" marL="0">
+            <a:pPr marL="0" indent="0">
               <a:buNone/>
             </a:pPr>
             <a:r>
@@ -1961,9 +1751,6 @@
               </a:rPr>
               <a:t>Cicero Martins Jr</a:t>
             </a:r>
-            <a:pPr indent="0" marL="0">
-              <a:buNone/>
-            </a:pPr>
             <a:r>
               <a:rPr lang="en-US" sz="1300" dirty="0">
                 <a:solidFill>
@@ -2000,7 +1787,7 @@
           <a:bodyPr wrap="square" lIns="0" tIns="0" rIns="0" bIns="0" rtlCol="0" anchor="ctr"/>
           <a:lstStyle/>
           <a:p>
-            <a:pPr indent="0" marL="0">
+            <a:pPr marL="0" indent="0">
               <a:buNone/>
             </a:pPr>
             <a:r>
@@ -2039,7 +1826,7 @@
           <a:bodyPr wrap="square" lIns="0" tIns="0" rIns="0" bIns="0" rtlCol="0" anchor="ctr"/>
           <a:lstStyle/>
           <a:p>
-            <a:pPr indent="0" marL="0">
+            <a:pPr marL="0" indent="0">
               <a:buNone/>
             </a:pPr>
             <a:r>
@@ -2103,11 +1890,11 @@
           <a:bodyPr wrap="square" lIns="0" tIns="0" rIns="0" bIns="0" rtlCol="0" anchor="ctr"/>
           <a:lstStyle/>
           <a:p>
-            <a:pPr indent="0" marL="0">
+            <a:pPr marL="0" indent="0">
               <a:buNone/>
             </a:pPr>
             <a:r>
-              <a:rPr lang="en-US" sz="1200" b="1" spc="200" kern="0" dirty="0">
+              <a:rPr lang="en-US" sz="1200" b="1" kern="0" spc="200" dirty="0">
                 <a:solidFill>
                   <a:srgbClr val="EB6834"/>
                 </a:solidFill>
@@ -2142,7 +1929,7 @@
           <a:bodyPr wrap="square" lIns="0" tIns="0" rIns="0" bIns="0" rtlCol="0" anchor="ctr"/>
           <a:lstStyle/>
           <a:p>
-            <a:pPr indent="0" marL="0">
+            <a:pPr marL="0" indent="0">
               <a:buNone/>
             </a:pPr>
             <a:r>
@@ -2179,6 +1966,13 @@
           </a:solidFill>
           <a:ln/>
         </p:spPr>
+        <p:txBody>
+          <a:bodyPr/>
+          <a:lstStyle/>
+          <a:p>
+            <a:endParaRPr lang="it-IT"/>
+          </a:p>
+        </p:txBody>
       </p:sp>
       <p:sp>
         <p:nvSpPr>
@@ -2201,7 +1995,7 @@
           <a:bodyPr wrap="square" lIns="0" tIns="0" rIns="0" bIns="0" rtlCol="0" anchor="ctr"/>
           <a:lstStyle/>
           <a:p>
-            <a:pPr algn="ctr" indent="0" marL="0">
+            <a:pPr marL="0" indent="0" algn="ctr">
               <a:buNone/>
             </a:pPr>
             <a:r>
@@ -2240,7 +2034,7 @@
           <a:bodyPr wrap="square" lIns="0" tIns="0" rIns="0" bIns="0" rtlCol="0" anchor="ctr"/>
           <a:lstStyle/>
           <a:p>
-            <a:pPr indent="0" marL="0">
+            <a:pPr marL="0" indent="0">
               <a:lnSpc>
                 <a:spcPts val="1600"/>
               </a:lnSpc>
@@ -2282,7 +2076,7 @@
           <a:bodyPr wrap="square" lIns="0" tIns="0" rIns="0" bIns="0" rtlCol="0" anchor="ctr"/>
           <a:lstStyle/>
           <a:p>
-            <a:pPr indent="0" marL="0">
+            <a:pPr marL="0" indent="0">
               <a:lnSpc>
                 <a:spcPts val="1450"/>
               </a:lnSpc>
@@ -2322,6 +2116,13 @@
           </a:solidFill>
           <a:ln/>
         </p:spPr>
+        <p:txBody>
+          <a:bodyPr/>
+          <a:lstStyle/>
+          <a:p>
+            <a:endParaRPr lang="it-IT"/>
+          </a:p>
+        </p:txBody>
       </p:sp>
       <p:sp>
         <p:nvSpPr>
@@ -2344,7 +2145,7 @@
           <a:bodyPr wrap="square" lIns="0" tIns="0" rIns="0" bIns="0" rtlCol="0" anchor="ctr"/>
           <a:lstStyle/>
           <a:p>
-            <a:pPr algn="ctr" indent="0" marL="0">
+            <a:pPr marL="0" indent="0" algn="ctr">
               <a:buNone/>
             </a:pPr>
             <a:r>
@@ -2383,7 +2184,7 @@
           <a:bodyPr wrap="square" lIns="0" tIns="0" rIns="0" bIns="0" rtlCol="0" anchor="ctr"/>
           <a:lstStyle/>
           <a:p>
-            <a:pPr indent="0" marL="0">
+            <a:pPr marL="0" indent="0">
               <a:lnSpc>
                 <a:spcPts val="1600"/>
               </a:lnSpc>
@@ -2425,7 +2226,7 @@
           <a:bodyPr wrap="square" lIns="0" tIns="0" rIns="0" bIns="0" rtlCol="0" anchor="ctr"/>
           <a:lstStyle/>
           <a:p>
-            <a:pPr indent="0" marL="0">
+            <a:pPr marL="0" indent="0">
               <a:lnSpc>
                 <a:spcPts val="1450"/>
               </a:lnSpc>
@@ -2465,6 +2266,13 @@
           </a:solidFill>
           <a:ln/>
         </p:spPr>
+        <p:txBody>
+          <a:bodyPr/>
+          <a:lstStyle/>
+          <a:p>
+            <a:endParaRPr lang="it-IT"/>
+          </a:p>
+        </p:txBody>
       </p:sp>
       <p:sp>
         <p:nvSpPr>
@@ -2487,7 +2295,7 @@
           <a:bodyPr wrap="square" lIns="0" tIns="0" rIns="0" bIns="0" rtlCol="0" anchor="ctr"/>
           <a:lstStyle/>
           <a:p>
-            <a:pPr algn="ctr" indent="0" marL="0">
+            <a:pPr marL="0" indent="0" algn="ctr">
               <a:buNone/>
             </a:pPr>
             <a:r>
@@ -2526,7 +2334,7 @@
           <a:bodyPr wrap="square" lIns="0" tIns="0" rIns="0" bIns="0" rtlCol="0" anchor="ctr"/>
           <a:lstStyle/>
           <a:p>
-            <a:pPr indent="0" marL="0">
+            <a:pPr marL="0" indent="0">
               <a:lnSpc>
                 <a:spcPts val="1600"/>
               </a:lnSpc>
@@ -2568,7 +2376,7 @@
           <a:bodyPr wrap="square" lIns="0" tIns="0" rIns="0" bIns="0" rtlCol="0" anchor="ctr"/>
           <a:lstStyle/>
           <a:p>
-            <a:pPr indent="0" marL="0">
+            <a:pPr marL="0" indent="0">
               <a:lnSpc>
                 <a:spcPts val="1450"/>
               </a:lnSpc>
@@ -2608,6 +2416,13 @@
           </a:solidFill>
           <a:ln/>
         </p:spPr>
+        <p:txBody>
+          <a:bodyPr/>
+          <a:lstStyle/>
+          <a:p>
+            <a:endParaRPr lang="it-IT"/>
+          </a:p>
+        </p:txBody>
       </p:sp>
       <p:sp>
         <p:nvSpPr>
@@ -2630,7 +2445,7 @@
           <a:bodyPr wrap="square" lIns="0" tIns="0" rIns="0" bIns="0" rtlCol="0" anchor="ctr"/>
           <a:lstStyle/>
           <a:p>
-            <a:pPr algn="ctr" indent="0" marL="0">
+            <a:pPr marL="0" indent="0" algn="ctr">
               <a:buNone/>
             </a:pPr>
             <a:r>
@@ -2669,7 +2484,7 @@
           <a:bodyPr wrap="square" lIns="0" tIns="0" rIns="0" bIns="0" rtlCol="0" anchor="ctr"/>
           <a:lstStyle/>
           <a:p>
-            <a:pPr indent="0" marL="0">
+            <a:pPr marL="0" indent="0">
               <a:lnSpc>
                 <a:spcPts val="1600"/>
               </a:lnSpc>
@@ -2711,7 +2526,7 @@
           <a:bodyPr wrap="square" lIns="0" tIns="0" rIns="0" bIns="0" rtlCol="0" anchor="ctr"/>
           <a:lstStyle/>
           <a:p>
-            <a:pPr indent="0" marL="0">
+            <a:pPr marL="0" indent="0">
               <a:lnSpc>
                 <a:spcPts val="1450"/>
               </a:lnSpc>
@@ -2751,6 +2566,13 @@
           </a:solidFill>
           <a:ln/>
         </p:spPr>
+        <p:txBody>
+          <a:bodyPr/>
+          <a:lstStyle/>
+          <a:p>
+            <a:endParaRPr lang="it-IT"/>
+          </a:p>
+        </p:txBody>
       </p:sp>
       <p:sp>
         <p:nvSpPr>
@@ -2773,7 +2595,7 @@
           <a:bodyPr wrap="square" lIns="0" tIns="0" rIns="0" bIns="0" rtlCol="0" anchor="ctr"/>
           <a:lstStyle/>
           <a:p>
-            <a:pPr algn="ctr" indent="0" marL="0">
+            <a:pPr marL="0" indent="0" algn="ctr">
               <a:buNone/>
             </a:pPr>
             <a:r>
@@ -2812,7 +2634,7 @@
           <a:bodyPr wrap="square" lIns="0" tIns="0" rIns="0" bIns="0" rtlCol="0" anchor="ctr"/>
           <a:lstStyle/>
           <a:p>
-            <a:pPr indent="0" marL="0">
+            <a:pPr marL="0" indent="0">
               <a:lnSpc>
                 <a:spcPts val="1600"/>
               </a:lnSpc>
@@ -2854,7 +2676,7 @@
           <a:bodyPr wrap="square" lIns="0" tIns="0" rIns="0" bIns="0" rtlCol="0" anchor="ctr"/>
           <a:lstStyle/>
           <a:p>
-            <a:pPr indent="0" marL="0">
+            <a:pPr marL="0" indent="0">
               <a:lnSpc>
                 <a:spcPts val="1450"/>
               </a:lnSpc>
@@ -2894,6 +2716,13 @@
           </a:solidFill>
           <a:ln/>
         </p:spPr>
+        <p:txBody>
+          <a:bodyPr/>
+          <a:lstStyle/>
+          <a:p>
+            <a:endParaRPr lang="it-IT"/>
+          </a:p>
+        </p:txBody>
       </p:sp>
       <p:sp>
         <p:nvSpPr>
@@ -2916,7 +2745,7 @@
           <a:bodyPr wrap="square" lIns="0" tIns="0" rIns="0" bIns="0" rtlCol="0" anchor="ctr"/>
           <a:lstStyle/>
           <a:p>
-            <a:pPr algn="ctr" indent="0" marL="0">
+            <a:pPr marL="0" indent="0" algn="ctr">
               <a:buNone/>
             </a:pPr>
             <a:r>
@@ -2955,7 +2784,7 @@
           <a:bodyPr wrap="square" lIns="0" tIns="0" rIns="0" bIns="0" rtlCol="0" anchor="ctr"/>
           <a:lstStyle/>
           <a:p>
-            <a:pPr indent="0" marL="0">
+            <a:pPr marL="0" indent="0">
               <a:lnSpc>
                 <a:spcPts val="1600"/>
               </a:lnSpc>
@@ -2997,7 +2826,7 @@
           <a:bodyPr wrap="square" lIns="0" tIns="0" rIns="0" bIns="0" rtlCol="0" anchor="ctr"/>
           <a:lstStyle/>
           <a:p>
-            <a:pPr indent="0" marL="0">
+            <a:pPr marL="0" indent="0">
               <a:lnSpc>
                 <a:spcPts val="1450"/>
               </a:lnSpc>
@@ -3034,6 +2863,7 @@
         <a:solidFill>
           <a:srgbClr val="21295C"/>
         </a:solidFill>
+        <a:effectLst/>
       </p:bgPr>
     </p:bg>
     <p:spTree>
@@ -3071,6 +2901,13 @@
           </a:solidFill>
           <a:ln/>
         </p:spPr>
+        <p:txBody>
+          <a:bodyPr/>
+          <a:lstStyle/>
+          <a:p>
+            <a:endParaRPr lang="it-IT"/>
+          </a:p>
+        </p:txBody>
       </p:sp>
       <p:sp>
         <p:nvSpPr>
@@ -3093,11 +2930,11 @@
           <a:bodyPr wrap="square" lIns="0" tIns="0" rIns="0" bIns="0" rtlCol="0" anchor="ctr"/>
           <a:lstStyle/>
           <a:p>
-            <a:pPr indent="0" marL="0">
+            <a:pPr marL="0" indent="0">
               <a:buNone/>
             </a:pPr>
             <a:r>
-              <a:rPr lang="en-US" sz="1200" b="1" spc="200" kern="0" dirty="0">
+              <a:rPr lang="en-US" sz="1200" b="1" kern="0" spc="200" dirty="0">
                 <a:solidFill>
                   <a:srgbClr val="EB6834"/>
                 </a:solidFill>
@@ -3132,7 +2969,7 @@
           <a:bodyPr wrap="square" lIns="0" tIns="0" rIns="0" bIns="0" rtlCol="0" anchor="ctr"/>
           <a:lstStyle/>
           <a:p>
-            <a:pPr indent="0" marL="0">
+            <a:pPr marL="0" indent="0">
               <a:buNone/>
             </a:pPr>
             <a:r>
@@ -3169,6 +3006,13 @@
           </a:solidFill>
           <a:ln/>
         </p:spPr>
+        <p:txBody>
+          <a:bodyPr/>
+          <a:lstStyle/>
+          <a:p>
+            <a:endParaRPr lang="it-IT"/>
+          </a:p>
+        </p:txBody>
       </p:sp>
       <p:sp>
         <p:nvSpPr>
@@ -3191,7 +3035,7 @@
           <a:bodyPr wrap="square" lIns="0" tIns="0" rIns="0" bIns="0" rtlCol="0" anchor="ctr"/>
           <a:lstStyle/>
           <a:p>
-            <a:pPr indent="0" marL="0">
+            <a:pPr marL="0" indent="0">
               <a:buNone/>
             </a:pPr>
             <a:r>
@@ -3230,7 +3074,7 @@
           <a:bodyPr wrap="square" lIns="0" tIns="0" rIns="0" bIns="0" rtlCol="0" anchor="ctr"/>
           <a:lstStyle/>
           <a:p>
-            <a:pPr indent="0" marL="0">
+            <a:pPr marL="0" indent="0">
               <a:lnSpc>
                 <a:spcPts val="1600"/>
               </a:lnSpc>
@@ -3270,6 +3114,13 @@
           </a:solidFill>
           <a:ln/>
         </p:spPr>
+        <p:txBody>
+          <a:bodyPr/>
+          <a:lstStyle/>
+          <a:p>
+            <a:endParaRPr lang="it-IT"/>
+          </a:p>
+        </p:txBody>
       </p:sp>
       <p:sp>
         <p:nvSpPr>
@@ -3292,7 +3143,7 @@
           <a:bodyPr wrap="square" lIns="0" tIns="0" rIns="0" bIns="0" rtlCol="0" anchor="ctr"/>
           <a:lstStyle/>
           <a:p>
-            <a:pPr indent="0" marL="0">
+            <a:pPr marL="0" indent="0">
               <a:buNone/>
             </a:pPr>
             <a:r>
@@ -3331,7 +3182,7 @@
           <a:bodyPr wrap="square" lIns="0" tIns="0" rIns="0" bIns="0" rtlCol="0" anchor="ctr"/>
           <a:lstStyle/>
           <a:p>
-            <a:pPr indent="0" marL="0">
+            <a:pPr marL="0" indent="0">
               <a:lnSpc>
                 <a:spcPts val="1600"/>
               </a:lnSpc>
@@ -3371,6 +3222,13 @@
           </a:solidFill>
           <a:ln/>
         </p:spPr>
+        <p:txBody>
+          <a:bodyPr/>
+          <a:lstStyle/>
+          <a:p>
+            <a:endParaRPr lang="it-IT"/>
+          </a:p>
+        </p:txBody>
       </p:sp>
       <p:sp>
         <p:nvSpPr>
@@ -3393,7 +3251,7 @@
           <a:bodyPr wrap="square" lIns="0" tIns="0" rIns="0" bIns="0" rtlCol="0" anchor="ctr"/>
           <a:lstStyle/>
           <a:p>
-            <a:pPr indent="0" marL="0">
+            <a:pPr marL="0" indent="0">
               <a:buNone/>
             </a:pPr>
             <a:r>
@@ -3432,7 +3290,7 @@
           <a:bodyPr wrap="square" lIns="0" tIns="0" rIns="0" bIns="0" rtlCol="0" anchor="ctr"/>
           <a:lstStyle/>
           <a:p>
-            <a:pPr indent="0" marL="0">
+            <a:pPr marL="0" indent="0">
               <a:lnSpc>
                 <a:spcPts val="1600"/>
               </a:lnSpc>
@@ -3472,6 +3330,13 @@
           </a:solidFill>
           <a:ln/>
         </p:spPr>
+        <p:txBody>
+          <a:bodyPr/>
+          <a:lstStyle/>
+          <a:p>
+            <a:endParaRPr lang="it-IT"/>
+          </a:p>
+        </p:txBody>
       </p:sp>
       <p:sp>
         <p:nvSpPr>
@@ -3494,7 +3359,7 @@
           <a:bodyPr wrap="square" lIns="0" tIns="0" rIns="0" bIns="0" rtlCol="0" anchor="ctr"/>
           <a:lstStyle/>
           <a:p>
-            <a:pPr indent="0" marL="0">
+            <a:pPr marL="0" indent="0">
               <a:buNone/>
             </a:pPr>
             <a:r>
@@ -3533,7 +3398,7 @@
           <a:bodyPr wrap="square" lIns="0" tIns="0" rIns="0" bIns="0" rtlCol="0" anchor="ctr"/>
           <a:lstStyle/>
           <a:p>
-            <a:pPr indent="0" marL="0">
+            <a:pPr marL="0" indent="0">
               <a:lnSpc>
                 <a:spcPts val="1600"/>
               </a:lnSpc>
@@ -3573,6 +3438,13 @@
           </a:solidFill>
           <a:ln/>
         </p:spPr>
+        <p:txBody>
+          <a:bodyPr/>
+          <a:lstStyle/>
+          <a:p>
+            <a:endParaRPr lang="it-IT"/>
+          </a:p>
+        </p:txBody>
       </p:sp>
       <p:sp>
         <p:nvSpPr>
@@ -3595,7 +3467,7 @@
           <a:bodyPr wrap="square" lIns="0" tIns="0" rIns="0" bIns="0" rtlCol="0" anchor="ctr"/>
           <a:lstStyle/>
           <a:p>
-            <a:pPr indent="0" marL="0">
+            <a:pPr marL="0" indent="0">
               <a:buNone/>
             </a:pPr>
             <a:r>
@@ -3634,7 +3506,7 @@
           <a:bodyPr wrap="square" lIns="0" tIns="0" rIns="0" bIns="0" rtlCol="0" anchor="ctr"/>
           <a:lstStyle/>
           <a:p>
-            <a:pPr indent="0" marL="0">
+            <a:pPr marL="0" indent="0">
               <a:lnSpc>
                 <a:spcPts val="1600"/>
               </a:lnSpc>
@@ -3676,7 +3548,7 @@
           <a:bodyPr wrap="square" lIns="0" tIns="0" rIns="0" bIns="0" rtlCol="0" anchor="ctr"/>
           <a:lstStyle/>
           <a:p>
-            <a:pPr indent="0" marL="0">
+            <a:pPr marL="0" indent="0">
               <a:buNone/>
             </a:pPr>
             <a:r>
@@ -3740,11 +3612,11 @@
           <a:bodyPr wrap="square" lIns="0" tIns="0" rIns="0" bIns="0" rtlCol="0" anchor="ctr"/>
           <a:lstStyle/>
           <a:p>
-            <a:pPr indent="0" marL="0">
+            <a:pPr marL="0" indent="0">
               <a:buNone/>
             </a:pPr>
             <a:r>
-              <a:rPr lang="en-US" sz="1200" b="1" spc="200" kern="0" dirty="0">
+              <a:rPr lang="en-US" sz="1200" b="1" kern="0" spc="200" dirty="0">
                 <a:solidFill>
                   <a:srgbClr val="EB6834"/>
                 </a:solidFill>
@@ -3779,7 +3651,7 @@
           <a:bodyPr wrap="square" lIns="0" tIns="0" rIns="0" bIns="0" rtlCol="0" anchor="ctr"/>
           <a:lstStyle/>
           <a:p>
-            <a:pPr indent="0" marL="0">
+            <a:pPr marL="0" indent="0">
               <a:buNone/>
             </a:pPr>
             <a:r>
@@ -3818,7 +3690,7 @@
           <a:bodyPr wrap="square" lIns="0" tIns="0" rIns="0" bIns="0" rtlCol="0" anchor="ctr"/>
           <a:lstStyle/>
           <a:p>
-            <a:pPr indent="0" marL="0">
+            <a:pPr marL="0" indent="0">
               <a:buNone/>
             </a:pPr>
             <a:r>
@@ -3857,7 +3729,7 @@
           <a:bodyPr wrap="square" lIns="0" tIns="0" rIns="0" bIns="0" rtlCol="0" anchor="ctr"/>
           <a:lstStyle/>
           <a:p>
-            <a:pPr indent="0" marL="0">
+            <a:pPr marL="0" indent="0">
               <a:lnSpc>
                 <a:spcPts val="2200"/>
               </a:lnSpc>
@@ -3880,7 +3752,7 @@
             <a:endParaRPr lang="en-US" sz="1450" dirty="0"/>
           </a:p>
           <a:p>
-            <a:pPr indent="0" marL="0">
+            <a:pPr marL="0" indent="0">
               <a:lnSpc>
                 <a:spcPts val="2200"/>
               </a:lnSpc>
@@ -3903,7 +3775,7 @@
             <a:endParaRPr lang="en-US" sz="1450" dirty="0"/>
           </a:p>
           <a:p>
-            <a:pPr indent="0" marL="0">
+            <a:pPr marL="0" indent="0">
               <a:lnSpc>
                 <a:spcPts val="2200"/>
               </a:lnSpc>
@@ -3926,7 +3798,7 @@
       </p:sp>
       <p:graphicFrame>
         <p:nvGraphicFramePr>
-          <p:cNvPr id="3" name="Table 0"/>
+          <p:cNvPr id="6" name="Table 0"/>
           <p:cNvGraphicFramePr>
             <a:graphicFrameLocks noGrp="1"/>
           </p:cNvGraphicFramePr>
@@ -3940,16 +3812,34 @@
         </p:nvGraphicFramePr>
         <p:xfrm>
           <a:off x="6263640" y="2057400"/>
-          <a:ext cx="5358384" cy="914400"/>
+          <a:ext cx="5358384" cy="2103120"/>
         </p:xfrm>
         <a:graphic>
           <a:graphicData uri="http://schemas.openxmlformats.org/drawingml/2006/table">
             <a:tbl>
               <a:tblPr/>
               <a:tblGrid>
-                <a:gridCol w="1700784"/>
-                <a:gridCol w="1828800"/>
-                <a:gridCol w="1828800"/>
+                <a:gridCol w="1700784">
+                  <a:extLst>
+                    <a:ext uri="{9D8B030D-6E8A-4147-A177-3AD203B41FA5}">
+                      <a16:colId xmlns:a16="http://schemas.microsoft.com/office/drawing/2014/main" val="20000"/>
+                    </a:ext>
+                  </a:extLst>
+                </a:gridCol>
+                <a:gridCol w="1828800">
+                  <a:extLst>
+                    <a:ext uri="{9D8B030D-6E8A-4147-A177-3AD203B41FA5}">
+                      <a16:colId xmlns:a16="http://schemas.microsoft.com/office/drawing/2014/main" val="20001"/>
+                    </a:ext>
+                  </a:extLst>
+                </a:gridCol>
+                <a:gridCol w="1828800">
+                  <a:extLst>
+                    <a:ext uri="{9D8B030D-6E8A-4147-A177-3AD203B41FA5}">
+                      <a16:colId xmlns:a16="http://schemas.microsoft.com/office/drawing/2014/main" val="20002"/>
+                    </a:ext>
+                  </a:extLst>
+                </a:gridCol>
               </a:tblGrid>
               <a:tr h="420624">
                 <a:tc>
@@ -3957,7 +3847,7 @@
                     <a:bodyPr/>
                     <a:lstStyle/>
                     <a:p>
-                      <a:pPr indent="0" marL="0">
+                      <a:pPr marL="0" indent="0">
                         <a:buNone/>
                       </a:pPr>
                       <a:endParaRPr lang="en-US" sz="1250" dirty="0">
@@ -3967,7 +3857,7 @@
                       </a:endParaRPr>
                     </a:p>
                   </a:txBody>
-                  <a:tcPr marL="91440" marR="91440" marT="45720" marB="45720" anchor="ctr">
+                  <a:tcPr anchor="ctr">
                     <a:lnL w="6350" cap="flat" cmpd="sng" algn="ctr">
                       <a:solidFill>
                         <a:srgbClr val="D6DEE3"/>
@@ -4014,7 +3904,7 @@
                     <a:bodyPr/>
                     <a:lstStyle/>
                     <a:p>
-                      <a:pPr indent="0" marL="0">
+                      <a:pPr marL="0" indent="0">
                         <a:buNone/>
                       </a:pPr>
                       <a:r>
@@ -4035,7 +3925,7 @@
                       </a:endParaRPr>
                     </a:p>
                   </a:txBody>
-                  <a:tcPr marL="91440" marR="91440" marT="45720" marB="45720" anchor="ctr">
+                  <a:tcPr anchor="ctr">
                     <a:lnL w="6350" cap="flat" cmpd="sng" algn="ctr">
                       <a:solidFill>
                         <a:srgbClr val="D6DEE3"/>
@@ -4082,7 +3972,7 @@
                     <a:bodyPr/>
                     <a:lstStyle/>
                     <a:p>
-                      <a:pPr indent="0" marL="0">
+                      <a:pPr marL="0" indent="0">
                         <a:buNone/>
                       </a:pPr>
                       <a:r>
@@ -4103,7 +3993,7 @@
                       </a:endParaRPr>
                     </a:p>
                   </a:txBody>
-                  <a:tcPr marL="91440" marR="91440" marT="45720" marB="45720" anchor="ctr">
+                  <a:tcPr anchor="ctr">
                     <a:lnL w="6350" cap="flat" cmpd="sng" algn="ctr">
                       <a:solidFill>
                         <a:srgbClr val="D6DEE3"/>
@@ -4145,6 +4035,11 @@
                     </a:solidFill>
                   </a:tcPr>
                 </a:tc>
+                <a:extLst>
+                  <a:ext uri="{0D108BD9-81ED-4DB2-BD59-A6C34878D82A}">
+                    <a16:rowId xmlns:a16="http://schemas.microsoft.com/office/drawing/2014/main" val="10000"/>
+                  </a:ext>
+                </a:extLst>
               </a:tr>
               <a:tr h="420624">
                 <a:tc>
@@ -4152,7 +4047,7 @@
                     <a:bodyPr/>
                     <a:lstStyle/>
                     <a:p>
-                      <a:pPr indent="0" marL="0">
+                      <a:pPr marL="0" indent="0">
                         <a:buNone/>
                       </a:pPr>
                       <a:r>
@@ -4173,7 +4068,7 @@
                       </a:endParaRPr>
                     </a:p>
                   </a:txBody>
-                  <a:tcPr marL="91440" marR="91440" marT="45720" marB="45720" anchor="ctr">
+                  <a:tcPr anchor="ctr">
                     <a:lnL w="6350" cap="flat" cmpd="sng" algn="ctr">
                       <a:solidFill>
                         <a:srgbClr val="D6DEE3"/>
@@ -4220,7 +4115,7 @@
                     <a:bodyPr/>
                     <a:lstStyle/>
                     <a:p>
-                      <a:pPr indent="0" marL="0">
+                      <a:pPr marL="0" indent="0">
                         <a:buNone/>
                       </a:pPr>
                       <a:r>
@@ -4241,7 +4136,7 @@
                       </a:endParaRPr>
                     </a:p>
                   </a:txBody>
-                  <a:tcPr marL="91440" marR="91440" marT="45720" marB="45720" anchor="ctr">
+                  <a:tcPr anchor="ctr">
                     <a:lnL w="6350" cap="flat" cmpd="sng" algn="ctr">
                       <a:solidFill>
                         <a:srgbClr val="D6DEE3"/>
@@ -4288,7 +4183,7 @@
                     <a:bodyPr/>
                     <a:lstStyle/>
                     <a:p>
-                      <a:pPr indent="0" marL="0">
+                      <a:pPr marL="0" indent="0">
                         <a:buNone/>
                       </a:pPr>
                       <a:r>
@@ -4309,7 +4204,7 @@
                       </a:endParaRPr>
                     </a:p>
                   </a:txBody>
-                  <a:tcPr marL="91440" marR="91440" marT="45720" marB="45720" anchor="ctr">
+                  <a:tcPr anchor="ctr">
                     <a:lnL w="6350" cap="flat" cmpd="sng" algn="ctr">
                       <a:solidFill>
                         <a:srgbClr val="D6DEE3"/>
@@ -4351,6 +4246,11 @@
                     </a:solidFill>
                   </a:tcPr>
                 </a:tc>
+                <a:extLst>
+                  <a:ext uri="{0D108BD9-81ED-4DB2-BD59-A6C34878D82A}">
+                    <a16:rowId xmlns:a16="http://schemas.microsoft.com/office/drawing/2014/main" val="10001"/>
+                  </a:ext>
+                </a:extLst>
               </a:tr>
               <a:tr h="420624">
                 <a:tc>
@@ -4358,7 +4258,7 @@
                     <a:bodyPr/>
                     <a:lstStyle/>
                     <a:p>
-                      <a:pPr indent="0" marL="0">
+                      <a:pPr marL="0" indent="0">
                         <a:buNone/>
                       </a:pPr>
                       <a:r>
@@ -4379,7 +4279,7 @@
                       </a:endParaRPr>
                     </a:p>
                   </a:txBody>
-                  <a:tcPr marL="91440" marR="91440" marT="45720" marB="45720" anchor="ctr">
+                  <a:tcPr anchor="ctr">
                     <a:lnL w="6350" cap="flat" cmpd="sng" algn="ctr">
                       <a:solidFill>
                         <a:srgbClr val="D6DEE3"/>
@@ -4426,7 +4326,7 @@
                     <a:bodyPr/>
                     <a:lstStyle/>
                     <a:p>
-                      <a:pPr indent="0" marL="0">
+                      <a:pPr marL="0" indent="0">
                         <a:buNone/>
                       </a:pPr>
                       <a:r>
@@ -4447,7 +4347,7 @@
                       </a:endParaRPr>
                     </a:p>
                   </a:txBody>
-                  <a:tcPr marL="91440" marR="91440" marT="45720" marB="45720" anchor="ctr">
+                  <a:tcPr anchor="ctr">
                     <a:lnL w="6350" cap="flat" cmpd="sng" algn="ctr">
                       <a:solidFill>
                         <a:srgbClr val="D6DEE3"/>
@@ -4494,7 +4394,7 @@
                     <a:bodyPr/>
                     <a:lstStyle/>
                     <a:p>
-                      <a:pPr indent="0" marL="0">
+                      <a:pPr marL="0" indent="0">
                         <a:buNone/>
                       </a:pPr>
                       <a:r>
@@ -4515,7 +4415,7 @@
                       </a:endParaRPr>
                     </a:p>
                   </a:txBody>
-                  <a:tcPr marL="91440" marR="91440" marT="45720" marB="45720" anchor="ctr">
+                  <a:tcPr anchor="ctr">
                     <a:lnL w="6350" cap="flat" cmpd="sng" algn="ctr">
                       <a:solidFill>
                         <a:srgbClr val="D6DEE3"/>
@@ -4557,6 +4457,11 @@
                     </a:solidFill>
                   </a:tcPr>
                 </a:tc>
+                <a:extLst>
+                  <a:ext uri="{0D108BD9-81ED-4DB2-BD59-A6C34878D82A}">
+                    <a16:rowId xmlns:a16="http://schemas.microsoft.com/office/drawing/2014/main" val="10002"/>
+                  </a:ext>
+                </a:extLst>
               </a:tr>
               <a:tr h="420624">
                 <a:tc>
@@ -4564,7 +4469,7 @@
                     <a:bodyPr/>
                     <a:lstStyle/>
                     <a:p>
-                      <a:pPr indent="0" marL="0">
+                      <a:pPr marL="0" indent="0">
                         <a:buNone/>
                       </a:pPr>
                       <a:r>
@@ -4585,7 +4490,7 @@
                       </a:endParaRPr>
                     </a:p>
                   </a:txBody>
-                  <a:tcPr marL="91440" marR="91440" marT="45720" marB="45720" anchor="ctr">
+                  <a:tcPr anchor="ctr">
                     <a:lnL w="6350" cap="flat" cmpd="sng" algn="ctr">
                       <a:solidFill>
                         <a:srgbClr val="D6DEE3"/>
@@ -4632,7 +4537,7 @@
                     <a:bodyPr/>
                     <a:lstStyle/>
                     <a:p>
-                      <a:pPr indent="0" marL="0">
+                      <a:pPr marL="0" indent="0">
                         <a:buNone/>
                       </a:pPr>
                       <a:r>
@@ -4653,7 +4558,7 @@
                       </a:endParaRPr>
                     </a:p>
                   </a:txBody>
-                  <a:tcPr marL="91440" marR="91440" marT="45720" marB="45720" anchor="ctr">
+                  <a:tcPr anchor="ctr">
                     <a:lnL w="6350" cap="flat" cmpd="sng" algn="ctr">
                       <a:solidFill>
                         <a:srgbClr val="D6DEE3"/>
@@ -4700,7 +4605,7 @@
                     <a:bodyPr/>
                     <a:lstStyle/>
                     <a:p>
-                      <a:pPr indent="0" marL="0">
+                      <a:pPr marL="0" indent="0">
                         <a:buNone/>
                       </a:pPr>
                       <a:r>
@@ -4721,7 +4626,7 @@
                       </a:endParaRPr>
                     </a:p>
                   </a:txBody>
-                  <a:tcPr marL="91440" marR="91440" marT="45720" marB="45720" anchor="ctr">
+                  <a:tcPr anchor="ctr">
                     <a:lnL w="6350" cap="flat" cmpd="sng" algn="ctr">
                       <a:solidFill>
                         <a:srgbClr val="D6DEE3"/>
@@ -4763,6 +4668,11 @@
                     </a:solidFill>
                   </a:tcPr>
                 </a:tc>
+                <a:extLst>
+                  <a:ext uri="{0D108BD9-81ED-4DB2-BD59-A6C34878D82A}">
+                    <a16:rowId xmlns:a16="http://schemas.microsoft.com/office/drawing/2014/main" val="10003"/>
+                  </a:ext>
+                </a:extLst>
               </a:tr>
               <a:tr h="420624">
                 <a:tc>
@@ -4770,7 +4680,7 @@
                     <a:bodyPr/>
                     <a:lstStyle/>
                     <a:p>
-                      <a:pPr indent="0" marL="0">
+                      <a:pPr marL="0" indent="0">
                         <a:buNone/>
                       </a:pPr>
                       <a:r>
@@ -4791,7 +4701,7 @@
                       </a:endParaRPr>
                     </a:p>
                   </a:txBody>
-                  <a:tcPr marL="91440" marR="91440" marT="45720" marB="45720" anchor="ctr">
+                  <a:tcPr anchor="ctr">
                     <a:lnL w="6350" cap="flat" cmpd="sng" algn="ctr">
                       <a:solidFill>
                         <a:srgbClr val="D6DEE3"/>
@@ -4838,7 +4748,7 @@
                     <a:bodyPr/>
                     <a:lstStyle/>
                     <a:p>
-                      <a:pPr indent="0" marL="0">
+                      <a:pPr marL="0" indent="0">
                         <a:buNone/>
                       </a:pPr>
                       <a:r>
@@ -4859,7 +4769,7 @@
                       </a:endParaRPr>
                     </a:p>
                   </a:txBody>
-                  <a:tcPr marL="91440" marR="91440" marT="45720" marB="45720" anchor="ctr">
+                  <a:tcPr anchor="ctr">
                     <a:lnL w="6350" cap="flat" cmpd="sng" algn="ctr">
                       <a:solidFill>
                         <a:srgbClr val="D6DEE3"/>
@@ -4906,7 +4816,7 @@
                     <a:bodyPr/>
                     <a:lstStyle/>
                     <a:p>
-                      <a:pPr indent="0" marL="0">
+                      <a:pPr marL="0" indent="0">
                         <a:buNone/>
                       </a:pPr>
                       <a:r>
@@ -4927,7 +4837,7 @@
                       </a:endParaRPr>
                     </a:p>
                   </a:txBody>
-                  <a:tcPr marL="91440" marR="91440" marT="45720" marB="45720" anchor="ctr">
+                  <a:tcPr anchor="ctr">
                     <a:lnL w="6350" cap="flat" cmpd="sng" algn="ctr">
                       <a:solidFill>
                         <a:srgbClr val="D6DEE3"/>
@@ -4969,6 +4879,11 @@
                     </a:solidFill>
                   </a:tcPr>
                 </a:tc>
+                <a:extLst>
+                  <a:ext uri="{0D108BD9-81ED-4DB2-BD59-A6C34878D82A}">
+                    <a16:rowId xmlns:a16="http://schemas.microsoft.com/office/drawing/2014/main" val="10004"/>
+                  </a:ext>
+                </a:extLst>
               </a:tr>
             </a:tbl>
           </a:graphicData>
@@ -4995,7 +4910,7 @@
           <a:bodyPr wrap="square" lIns="0" tIns="0" rIns="0" bIns="0" rtlCol="0" anchor="ctr"/>
           <a:lstStyle/>
           <a:p>
-            <a:pPr indent="0" marL="0">
+            <a:pPr marL="0" indent="0">
               <a:buNone/>
             </a:pPr>
             <a:r>
@@ -5059,11 +4974,11 @@
           <a:bodyPr wrap="square" lIns="0" tIns="0" rIns="0" bIns="0" rtlCol="0" anchor="ctr"/>
           <a:lstStyle/>
           <a:p>
-            <a:pPr indent="0" marL="0">
+            <a:pPr marL="0" indent="0">
               <a:buNone/>
             </a:pPr>
             <a:r>
-              <a:rPr lang="en-US" sz="1200" b="1" spc="200" kern="0" dirty="0">
+              <a:rPr lang="en-US" sz="1200" b="1" kern="0" spc="200" dirty="0">
                 <a:solidFill>
                   <a:srgbClr val="EB6834"/>
                 </a:solidFill>
@@ -5098,7 +5013,7 @@
           <a:bodyPr wrap="square" lIns="0" tIns="0" rIns="0" bIns="0" rtlCol="0" anchor="ctr"/>
           <a:lstStyle/>
           <a:p>
-            <a:pPr indent="0" marL="0">
+            <a:pPr marL="0" indent="0">
               <a:buNone/>
             </a:pPr>
             <a:r>
@@ -5137,7 +5052,7 @@
           <a:bodyPr wrap="square" lIns="0" tIns="0" rIns="0" bIns="0" rtlCol="0" anchor="ctr"/>
           <a:lstStyle/>
           <a:p>
-            <a:pPr indent="0" marL="0">
+            <a:pPr marL="0" indent="0">
               <a:buNone/>
             </a:pPr>
             <a:r>
@@ -5176,7 +5091,7 @@
           <a:bodyPr wrap="square" lIns="0" tIns="0" rIns="0" bIns="0" rtlCol="0" anchor="ctr"/>
           <a:lstStyle/>
           <a:p>
-            <a:pPr indent="0" marL="0">
+            <a:pPr marL="0" indent="0">
               <a:buNone/>
             </a:pPr>
             <a:r>
@@ -5215,7 +5130,7 @@
           <a:bodyPr wrap="square" lIns="0" tIns="0" rIns="0" bIns="0" rtlCol="0" anchor="ctr"/>
           <a:lstStyle/>
           <a:p>
-            <a:pPr indent="0" marL="0">
+            <a:pPr marL="0" indent="0">
               <a:buNone/>
             </a:pPr>
             <a:r>
@@ -5232,7 +5147,7 @@
             <a:endParaRPr lang="en-US" sz="1200" dirty="0"/>
           </a:p>
           <a:p>
-            <a:pPr indent="0" marL="0">
+            <a:pPr marL="0" indent="0">
               <a:buNone/>
             </a:pPr>
             <a:r>
@@ -5271,7 +5186,7 @@
           <a:bodyPr wrap="square" lIns="0" tIns="0" rIns="0" bIns="0" rtlCol="0" anchor="ctr"/>
           <a:lstStyle/>
           <a:p>
-            <a:pPr indent="0" marL="0">
+            <a:pPr marL="0" indent="0">
               <a:buNone/>
             </a:pPr>
             <a:r>
@@ -5310,7 +5225,7 @@
           <a:bodyPr wrap="square" lIns="0" tIns="0" rIns="0" bIns="0" rtlCol="0" anchor="ctr"/>
           <a:lstStyle/>
           <a:p>
-            <a:pPr indent="0" marL="0">
+            <a:pPr marL="0" indent="0">
               <a:buNone/>
             </a:pPr>
             <a:r>
@@ -5327,7 +5242,7 @@
             <a:endParaRPr lang="en-US" sz="1200" dirty="0"/>
           </a:p>
           <a:p>
-            <a:pPr indent="0" marL="0">
+            <a:pPr marL="0" indent="0">
               <a:buNone/>
             </a:pPr>
             <a:r>
@@ -5366,7 +5281,7 @@
           <a:bodyPr wrap="square" lIns="0" tIns="0" rIns="0" bIns="0" rtlCol="0" anchor="ctr"/>
           <a:lstStyle/>
           <a:p>
-            <a:pPr indent="0" marL="0">
+            <a:pPr marL="0" indent="0">
               <a:buNone/>
             </a:pPr>
             <a:r>
@@ -5405,7 +5320,7 @@
           <a:bodyPr wrap="square" lIns="0" tIns="0" rIns="0" bIns="0" rtlCol="0" anchor="ctr"/>
           <a:lstStyle/>
           <a:p>
-            <a:pPr indent="0" marL="0">
+            <a:pPr marL="0" indent="0">
               <a:buNone/>
             </a:pPr>
             <a:r>
@@ -5422,7 +5337,7 @@
             <a:endParaRPr lang="en-US" sz="1200" dirty="0"/>
           </a:p>
           <a:p>
-            <a:pPr indent="0" marL="0">
+            <a:pPr marL="0" indent="0">
               <a:buNone/>
             </a:pPr>
             <a:r>
@@ -5442,14 +5357,14 @@
       </p:sp>
       <p:pic>
         <p:nvPicPr>
-          <p:cNvPr id="11" name="Image 0" descr="C:\Users\Unipa\Documents\MaltaDT\figures\bathymetry_overview.png">    </p:cNvPr>
+          <p:cNvPr id="11" name="Image 0" descr="C:\Users\Unipa\Documents\MaltaDT\figures\bathymetry_overview.png"/>
           <p:cNvPicPr>
             <a:picLocks noChangeAspect="1"/>
           </p:cNvPicPr>
           <p:nvPr/>
         </p:nvPicPr>
         <p:blipFill>
-          <a:blip r:embed="rId1"/>
+          <a:blip r:embed="rId3"/>
           <a:stretch>
             <a:fillRect/>
           </a:stretch>
@@ -5485,7 +5400,7 @@
           <a:bodyPr wrap="square" lIns="0" tIns="0" rIns="0" bIns="0" rtlCol="0" anchor="ctr"/>
           <a:lstStyle/>
           <a:p>
-            <a:pPr indent="0" marL="0">
+            <a:pPr marL="0" indent="0">
               <a:lnSpc>
                 <a:spcPts val="1600"/>
               </a:lnSpc>
@@ -5506,7 +5421,7 @@
             <a:endParaRPr lang="en-US" sz="1150" dirty="0"/>
           </a:p>
           <a:p>
-            <a:pPr indent="0" marL="0">
+            <a:pPr marL="0" indent="0">
               <a:lnSpc>
                 <a:spcPts val="1600"/>
               </a:lnSpc>
@@ -5527,7 +5442,7 @@
             <a:endParaRPr lang="en-US" sz="1150" dirty="0"/>
           </a:p>
           <a:p>
-            <a:pPr indent="0" marL="0">
+            <a:pPr marL="0" indent="0">
               <a:lnSpc>
                 <a:spcPts val="1600"/>
               </a:lnSpc>
@@ -5569,7 +5484,7 @@
           <a:bodyPr wrap="square" lIns="0" tIns="0" rIns="0" bIns="0" rtlCol="0" anchor="ctr"/>
           <a:lstStyle/>
           <a:p>
-            <a:pPr indent="0" marL="0">
+            <a:pPr marL="0" indent="0">
               <a:buNone/>
             </a:pPr>
             <a:r>
@@ -5633,11 +5548,11 @@
           <a:bodyPr wrap="square" lIns="0" tIns="0" rIns="0" bIns="0" rtlCol="0" anchor="ctr"/>
           <a:lstStyle/>
           <a:p>
-            <a:pPr indent="0" marL="0">
+            <a:pPr marL="0" indent="0">
               <a:buNone/>
             </a:pPr>
             <a:r>
-              <a:rPr lang="en-US" sz="1200" b="1" spc="200" kern="0" dirty="0">
+              <a:rPr lang="en-US" sz="1200" b="1" kern="0" spc="200" dirty="0">
                 <a:solidFill>
                   <a:srgbClr val="EB6834"/>
                 </a:solidFill>
@@ -5672,7 +5587,7 @@
           <a:bodyPr wrap="square" lIns="0" tIns="0" rIns="0" bIns="0" rtlCol="0" anchor="ctr"/>
           <a:lstStyle/>
           <a:p>
-            <a:pPr indent="0" marL="0">
+            <a:pPr marL="0" indent="0">
               <a:buNone/>
             </a:pPr>
             <a:r>
@@ -5711,7 +5626,7 @@
           <a:bodyPr wrap="square" lIns="0" tIns="0" rIns="0" bIns="0" rtlCol="0" anchor="ctr"/>
           <a:lstStyle/>
           <a:p>
-            <a:pPr indent="0" marL="0">
+            <a:pPr marL="0" indent="0">
               <a:buNone/>
             </a:pPr>
             <a:r>
@@ -5750,6 +5665,13 @@
           </a:solidFill>
           <a:ln/>
         </p:spPr>
+        <p:txBody>
+          <a:bodyPr/>
+          <a:lstStyle/>
+          <a:p>
+            <a:endParaRPr lang="it-IT"/>
+          </a:p>
+        </p:txBody>
       </p:sp>
       <p:sp>
         <p:nvSpPr>
@@ -5770,6 +5692,13 @@
           </a:solidFill>
           <a:ln/>
         </p:spPr>
+        <p:txBody>
+          <a:bodyPr/>
+          <a:lstStyle/>
+          <a:p>
+            <a:endParaRPr lang="it-IT"/>
+          </a:p>
+        </p:txBody>
       </p:sp>
       <p:sp>
         <p:nvSpPr>
@@ -5792,7 +5721,7 @@
           <a:bodyPr wrap="square" lIns="0" tIns="0" rIns="0" bIns="0" rtlCol="0" anchor="ctr"/>
           <a:lstStyle/>
           <a:p>
-            <a:pPr algn="ctr" indent="0" marL="0">
+            <a:pPr marL="0" indent="0" algn="ctr">
               <a:buNone/>
             </a:pPr>
             <a:r>
@@ -5831,7 +5760,7 @@
           <a:bodyPr wrap="square" lIns="0" tIns="0" rIns="0" bIns="0" rtlCol="0" anchor="ctr"/>
           <a:lstStyle/>
           <a:p>
-            <a:pPr indent="0" marL="0">
+            <a:pPr marL="0" indent="0">
               <a:buNone/>
             </a:pPr>
             <a:r>
@@ -5870,7 +5799,7 @@
           <a:bodyPr wrap="square" lIns="0" tIns="0" rIns="0" bIns="0" rtlCol="0" anchor="ctr"/>
           <a:lstStyle/>
           <a:p>
-            <a:pPr indent="0" marL="0">
+            <a:pPr marL="0" indent="0">
               <a:lnSpc>
                 <a:spcPts val="1600"/>
               </a:lnSpc>
@@ -5912,7 +5841,7 @@
           <a:bodyPr wrap="square" lIns="0" tIns="0" rIns="0" bIns="0" rtlCol="0" anchor="ctr"/>
           <a:lstStyle/>
           <a:p>
-            <a:pPr indent="0" marL="0">
+            <a:pPr marL="0" indent="0">
               <a:lnSpc>
                 <a:spcPts val="1500"/>
               </a:lnSpc>
@@ -5954,6 +5883,13 @@
           </a:solidFill>
           <a:ln/>
         </p:spPr>
+        <p:txBody>
+          <a:bodyPr/>
+          <a:lstStyle/>
+          <a:p>
+            <a:endParaRPr lang="it-IT"/>
+          </a:p>
+        </p:txBody>
       </p:sp>
       <p:sp>
         <p:nvSpPr>
@@ -5974,6 +5910,13 @@
           </a:solidFill>
           <a:ln/>
         </p:spPr>
+        <p:txBody>
+          <a:bodyPr/>
+          <a:lstStyle/>
+          <a:p>
+            <a:endParaRPr lang="it-IT"/>
+          </a:p>
+        </p:txBody>
       </p:sp>
       <p:sp>
         <p:nvSpPr>
@@ -5996,7 +5939,7 @@
           <a:bodyPr wrap="square" lIns="0" tIns="0" rIns="0" bIns="0" rtlCol="0" anchor="ctr"/>
           <a:lstStyle/>
           <a:p>
-            <a:pPr algn="ctr" indent="0" marL="0">
+            <a:pPr marL="0" indent="0" algn="ctr">
               <a:buNone/>
             </a:pPr>
             <a:r>
@@ -6035,7 +5978,7 @@
           <a:bodyPr wrap="square" lIns="0" tIns="0" rIns="0" bIns="0" rtlCol="0" anchor="ctr"/>
           <a:lstStyle/>
           <a:p>
-            <a:pPr indent="0" marL="0">
+            <a:pPr marL="0" indent="0">
               <a:buNone/>
             </a:pPr>
             <a:r>
@@ -6074,7 +6017,7 @@
           <a:bodyPr wrap="square" lIns="0" tIns="0" rIns="0" bIns="0" rtlCol="0" anchor="ctr"/>
           <a:lstStyle/>
           <a:p>
-            <a:pPr indent="0" marL="0">
+            <a:pPr marL="0" indent="0">
               <a:lnSpc>
                 <a:spcPts val="1600"/>
               </a:lnSpc>
@@ -6116,7 +6059,7 @@
           <a:bodyPr wrap="square" lIns="0" tIns="0" rIns="0" bIns="0" rtlCol="0" anchor="ctr"/>
           <a:lstStyle/>
           <a:p>
-            <a:pPr indent="0" marL="0">
+            <a:pPr marL="0" indent="0">
               <a:lnSpc>
                 <a:spcPts val="1500"/>
               </a:lnSpc>
@@ -6158,6 +6101,13 @@
           </a:solidFill>
           <a:ln/>
         </p:spPr>
+        <p:txBody>
+          <a:bodyPr/>
+          <a:lstStyle/>
+          <a:p>
+            <a:endParaRPr lang="it-IT"/>
+          </a:p>
+        </p:txBody>
       </p:sp>
       <p:sp>
         <p:nvSpPr>
@@ -6178,6 +6128,13 @@
           </a:solidFill>
           <a:ln/>
         </p:spPr>
+        <p:txBody>
+          <a:bodyPr/>
+          <a:lstStyle/>
+          <a:p>
+            <a:endParaRPr lang="it-IT"/>
+          </a:p>
+        </p:txBody>
       </p:sp>
       <p:sp>
         <p:nvSpPr>
@@ -6200,7 +6157,7 @@
           <a:bodyPr wrap="square" lIns="0" tIns="0" rIns="0" bIns="0" rtlCol="0" anchor="ctr"/>
           <a:lstStyle/>
           <a:p>
-            <a:pPr algn="ctr" indent="0" marL="0">
+            <a:pPr marL="0" indent="0" algn="ctr">
               <a:buNone/>
             </a:pPr>
             <a:r>
@@ -6239,7 +6196,7 @@
           <a:bodyPr wrap="square" lIns="0" tIns="0" rIns="0" bIns="0" rtlCol="0" anchor="ctr"/>
           <a:lstStyle/>
           <a:p>
-            <a:pPr indent="0" marL="0">
+            <a:pPr marL="0" indent="0">
               <a:buNone/>
             </a:pPr>
             <a:r>
@@ -6278,7 +6235,7 @@
           <a:bodyPr wrap="square" lIns="0" tIns="0" rIns="0" bIns="0" rtlCol="0" anchor="ctr"/>
           <a:lstStyle/>
           <a:p>
-            <a:pPr indent="0" marL="0">
+            <a:pPr marL="0" indent="0">
               <a:lnSpc>
                 <a:spcPts val="1600"/>
               </a:lnSpc>
@@ -6320,7 +6277,7 @@
           <a:bodyPr wrap="square" lIns="0" tIns="0" rIns="0" bIns="0" rtlCol="0" anchor="ctr"/>
           <a:lstStyle/>
           <a:p>
-            <a:pPr indent="0" marL="0">
+            <a:pPr marL="0" indent="0">
               <a:lnSpc>
                 <a:spcPts val="1500"/>
               </a:lnSpc>
@@ -6362,7 +6319,7 @@
           <a:bodyPr wrap="square" lIns="0" tIns="0" rIns="0" bIns="0" rtlCol="0" anchor="ctr"/>
           <a:lstStyle/>
           <a:p>
-            <a:pPr indent="0" marL="0">
+            <a:pPr marL="0" indent="0">
               <a:buNone/>
             </a:pPr>
             <a:r>
@@ -6426,11 +6383,11 @@
           <a:bodyPr wrap="square" lIns="0" tIns="0" rIns="0" bIns="0" rtlCol="0" anchor="ctr"/>
           <a:lstStyle/>
           <a:p>
-            <a:pPr indent="0" marL="0">
+            <a:pPr marL="0" indent="0">
               <a:buNone/>
             </a:pPr>
             <a:r>
-              <a:rPr lang="en-US" sz="1200" b="1" spc="200" kern="0" dirty="0">
+              <a:rPr lang="en-US" sz="1200" b="1" kern="0" spc="200" dirty="0">
                 <a:solidFill>
                   <a:srgbClr val="EB6834"/>
                 </a:solidFill>
@@ -6465,7 +6422,7 @@
           <a:bodyPr wrap="square" lIns="0" tIns="0" rIns="0" bIns="0" rtlCol="0" anchor="ctr"/>
           <a:lstStyle/>
           <a:p>
-            <a:pPr indent="0" marL="0">
+            <a:pPr marL="0" indent="0">
               <a:buNone/>
             </a:pPr>
             <a:r>
@@ -6504,7 +6461,7 @@
           <a:bodyPr wrap="square" lIns="0" tIns="0" rIns="0" bIns="0" rtlCol="0" anchor="ctr"/>
           <a:lstStyle/>
           <a:p>
-            <a:pPr indent="0" marL="0">
+            <a:pPr marL="0" indent="0">
               <a:buNone/>
             </a:pPr>
             <a:r>
@@ -6538,19 +6495,55 @@
         </p:nvGraphicFramePr>
         <p:xfrm>
           <a:off x="566928" y="2286000"/>
-          <a:ext cx="7772400" cy="914400"/>
+          <a:ext cx="7772400" cy="2400300"/>
         </p:xfrm>
         <a:graphic>
           <a:graphicData uri="http://schemas.openxmlformats.org/drawingml/2006/table">
             <a:tbl>
               <a:tblPr/>
               <a:tblGrid>
-                <a:gridCol w="2743200"/>
-                <a:gridCol w="868680"/>
-                <a:gridCol w="777240"/>
-                <a:gridCol w="960120"/>
-                <a:gridCol w="1051560"/>
-                <a:gridCol w="1371600"/>
+                <a:gridCol w="2743200">
+                  <a:extLst>
+                    <a:ext uri="{9D8B030D-6E8A-4147-A177-3AD203B41FA5}">
+                      <a16:colId xmlns:a16="http://schemas.microsoft.com/office/drawing/2014/main" val="20000"/>
+                    </a:ext>
+                  </a:extLst>
+                </a:gridCol>
+                <a:gridCol w="868680">
+                  <a:extLst>
+                    <a:ext uri="{9D8B030D-6E8A-4147-A177-3AD203B41FA5}">
+                      <a16:colId xmlns:a16="http://schemas.microsoft.com/office/drawing/2014/main" val="20001"/>
+                    </a:ext>
+                  </a:extLst>
+                </a:gridCol>
+                <a:gridCol w="777240">
+                  <a:extLst>
+                    <a:ext uri="{9D8B030D-6E8A-4147-A177-3AD203B41FA5}">
+                      <a16:colId xmlns:a16="http://schemas.microsoft.com/office/drawing/2014/main" val="20002"/>
+                    </a:ext>
+                  </a:extLst>
+                </a:gridCol>
+                <a:gridCol w="960120">
+                  <a:extLst>
+                    <a:ext uri="{9D8B030D-6E8A-4147-A177-3AD203B41FA5}">
+                      <a16:colId xmlns:a16="http://schemas.microsoft.com/office/drawing/2014/main" val="20003"/>
+                    </a:ext>
+                  </a:extLst>
+                </a:gridCol>
+                <a:gridCol w="1051560">
+                  <a:extLst>
+                    <a:ext uri="{9D8B030D-6E8A-4147-A177-3AD203B41FA5}">
+                      <a16:colId xmlns:a16="http://schemas.microsoft.com/office/drawing/2014/main" val="20004"/>
+                    </a:ext>
+                  </a:extLst>
+                </a:gridCol>
+                <a:gridCol w="1371600">
+                  <a:extLst>
+                    <a:ext uri="{9D8B030D-6E8A-4147-A177-3AD203B41FA5}">
+                      <a16:colId xmlns:a16="http://schemas.microsoft.com/office/drawing/2014/main" val="20005"/>
+                    </a:ext>
+                  </a:extLst>
+                </a:gridCol>
               </a:tblGrid>
               <a:tr h="342900">
                 <a:tc>
@@ -6558,7 +6551,7 @@
                     <a:bodyPr/>
                     <a:lstStyle/>
                     <a:p>
-                      <a:pPr algn="l" indent="0" marL="0">
+                      <a:pPr marL="0" indent="0" algn="l">
                         <a:buNone/>
                       </a:pPr>
                       <a:r>
@@ -6579,7 +6572,7 @@
                       </a:endParaRPr>
                     </a:p>
                   </a:txBody>
-                  <a:tcPr marL="91440" marR="91440" marT="45720" marB="45720" anchor="ctr">
+                  <a:tcPr anchor="ctr">
                     <a:lnL w="6350" cap="flat" cmpd="sng" algn="ctr">
                       <a:solidFill>
                         <a:srgbClr val="E2E8EC"/>
@@ -6626,7 +6619,7 @@
                     <a:bodyPr/>
                     <a:lstStyle/>
                     <a:p>
-                      <a:pPr algn="r" indent="0" marL="0">
+                      <a:pPr marL="0" indent="0" algn="r">
                         <a:buNone/>
                       </a:pPr>
                       <a:r>
@@ -6647,7 +6640,7 @@
                       </a:endParaRPr>
                     </a:p>
                   </a:txBody>
-                  <a:tcPr marL="91440" marR="91440" marT="45720" marB="45720" anchor="ctr">
+                  <a:tcPr anchor="ctr">
                     <a:lnL w="6350" cap="flat" cmpd="sng" algn="ctr">
                       <a:solidFill>
                         <a:srgbClr val="E2E8EC"/>
@@ -6694,7 +6687,7 @@
                     <a:bodyPr/>
                     <a:lstStyle/>
                     <a:p>
-                      <a:pPr algn="r" indent="0" marL="0">
+                      <a:pPr marL="0" indent="0" algn="r">
                         <a:buNone/>
                       </a:pPr>
                       <a:r>
@@ -6715,7 +6708,7 @@
                       </a:endParaRPr>
                     </a:p>
                   </a:txBody>
-                  <a:tcPr marL="91440" marR="91440" marT="45720" marB="45720" anchor="ctr">
+                  <a:tcPr anchor="ctr">
                     <a:lnL w="6350" cap="flat" cmpd="sng" algn="ctr">
                       <a:solidFill>
                         <a:srgbClr val="E2E8EC"/>
@@ -6762,7 +6755,7 @@
                     <a:bodyPr/>
                     <a:lstStyle/>
                     <a:p>
-                      <a:pPr algn="r" indent="0" marL="0">
+                      <a:pPr marL="0" indent="0" algn="r">
                         <a:buNone/>
                       </a:pPr>
                       <a:r>
@@ -6783,7 +6776,7 @@
                       </a:endParaRPr>
                     </a:p>
                   </a:txBody>
-                  <a:tcPr marL="91440" marR="91440" marT="45720" marB="45720" anchor="ctr">
+                  <a:tcPr anchor="ctr">
                     <a:lnL w="6350" cap="flat" cmpd="sng" algn="ctr">
                       <a:solidFill>
                         <a:srgbClr val="E2E8EC"/>
@@ -6830,7 +6823,7 @@
                     <a:bodyPr/>
                     <a:lstStyle/>
                     <a:p>
-                      <a:pPr algn="r" indent="0" marL="0">
+                      <a:pPr marL="0" indent="0" algn="r">
                         <a:buNone/>
                       </a:pPr>
                       <a:r>
@@ -6851,7 +6844,7 @@
                       </a:endParaRPr>
                     </a:p>
                   </a:txBody>
-                  <a:tcPr marL="91440" marR="91440" marT="45720" marB="45720" anchor="ctr">
+                  <a:tcPr anchor="ctr">
                     <a:lnL w="6350" cap="flat" cmpd="sng" algn="ctr">
                       <a:solidFill>
                         <a:srgbClr val="E2E8EC"/>
@@ -6898,7 +6891,7 @@
                     <a:bodyPr/>
                     <a:lstStyle/>
                     <a:p>
-                      <a:pPr algn="l" indent="0" marL="0">
+                      <a:pPr marL="0" indent="0" algn="l">
                         <a:buNone/>
                       </a:pPr>
                       <a:endParaRPr lang="en-US" sz="1200" dirty="0">
@@ -6908,7 +6901,7 @@
                       </a:endParaRPr>
                     </a:p>
                   </a:txBody>
-                  <a:tcPr marL="91440" marR="91440" marT="45720" marB="45720" anchor="ctr">
+                  <a:tcPr anchor="ctr">
                     <a:lnL w="6350" cap="flat" cmpd="sng" algn="ctr">
                       <a:solidFill>
                         <a:srgbClr val="E2E8EC"/>
@@ -6950,6 +6943,11 @@
                     </a:solidFill>
                   </a:tcPr>
                 </a:tc>
+                <a:extLst>
+                  <a:ext uri="{0D108BD9-81ED-4DB2-BD59-A6C34878D82A}">
+                    <a16:rowId xmlns:a16="http://schemas.microsoft.com/office/drawing/2014/main" val="10000"/>
+                  </a:ext>
+                </a:extLst>
               </a:tr>
               <a:tr h="342900">
                 <a:tc>
@@ -6957,7 +6955,7 @@
                     <a:bodyPr/>
                     <a:lstStyle/>
                     <a:p>
-                      <a:pPr algn="l" indent="0" marL="0">
+                      <a:pPr marL="0" indent="0" algn="l">
                         <a:buNone/>
                       </a:pPr>
                       <a:r>
@@ -6978,7 +6976,7 @@
                       </a:endParaRPr>
                     </a:p>
                   </a:txBody>
-                  <a:tcPr marL="91440" marR="91440" marT="45720" marB="45720" anchor="ctr">
+                  <a:tcPr anchor="ctr">
                     <a:lnL w="6350" cap="flat" cmpd="sng" algn="ctr">
                       <a:solidFill>
                         <a:srgbClr val="E2E8EC"/>
@@ -7025,7 +7023,7 @@
                     <a:bodyPr/>
                     <a:lstStyle/>
                     <a:p>
-                      <a:pPr algn="r" indent="0" marL="0">
+                      <a:pPr marL="0" indent="0" algn="r">
                         <a:buNone/>
                       </a:pPr>
                       <a:r>
@@ -7046,7 +7044,7 @@
                       </a:endParaRPr>
                     </a:p>
                   </a:txBody>
-                  <a:tcPr marL="91440" marR="91440" marT="45720" marB="45720" anchor="ctr">
+                  <a:tcPr anchor="ctr">
                     <a:lnL w="6350" cap="flat" cmpd="sng" algn="ctr">
                       <a:solidFill>
                         <a:srgbClr val="E2E8EC"/>
@@ -7093,7 +7091,7 @@
                     <a:bodyPr/>
                     <a:lstStyle/>
                     <a:p>
-                      <a:pPr algn="r" indent="0" marL="0">
+                      <a:pPr marL="0" indent="0" algn="r">
                         <a:buNone/>
                       </a:pPr>
                       <a:r>
@@ -7114,7 +7112,7 @@
                       </a:endParaRPr>
                     </a:p>
                   </a:txBody>
-                  <a:tcPr marL="91440" marR="91440" marT="45720" marB="45720" anchor="ctr">
+                  <a:tcPr anchor="ctr">
                     <a:lnL w="6350" cap="flat" cmpd="sng" algn="ctr">
                       <a:solidFill>
                         <a:srgbClr val="E2E8EC"/>
@@ -7161,7 +7159,7 @@
                     <a:bodyPr/>
                     <a:lstStyle/>
                     <a:p>
-                      <a:pPr algn="r" indent="0" marL="0">
+                      <a:pPr marL="0" indent="0" algn="r">
                         <a:buNone/>
                       </a:pPr>
                       <a:r>
@@ -7182,7 +7180,7 @@
                       </a:endParaRPr>
                     </a:p>
                   </a:txBody>
-                  <a:tcPr marL="91440" marR="91440" marT="45720" marB="45720" anchor="ctr">
+                  <a:tcPr anchor="ctr">
                     <a:lnL w="6350" cap="flat" cmpd="sng" algn="ctr">
                       <a:solidFill>
                         <a:srgbClr val="E2E8EC"/>
@@ -7229,7 +7227,7 @@
                     <a:bodyPr/>
                     <a:lstStyle/>
                     <a:p>
-                      <a:pPr algn="r" indent="0" marL="0">
+                      <a:pPr marL="0" indent="0" algn="r">
                         <a:buNone/>
                       </a:pPr>
                       <a:r>
@@ -7250,7 +7248,7 @@
                       </a:endParaRPr>
                     </a:p>
                   </a:txBody>
-                  <a:tcPr marL="91440" marR="91440" marT="45720" marB="45720" anchor="ctr">
+                  <a:tcPr anchor="ctr">
                     <a:lnL w="6350" cap="flat" cmpd="sng" algn="ctr">
                       <a:solidFill>
                         <a:srgbClr val="E2E8EC"/>
@@ -7297,7 +7295,7 @@
                     <a:bodyPr/>
                     <a:lstStyle/>
                     <a:p>
-                      <a:pPr algn="l" indent="0" marL="0">
+                      <a:pPr marL="0" indent="0" algn="l">
                         <a:buNone/>
                       </a:pPr>
                       <a:r>
@@ -7318,7 +7316,7 @@
                       </a:endParaRPr>
                     </a:p>
                   </a:txBody>
-                  <a:tcPr marL="91440" marR="91440" marT="45720" marB="45720" anchor="ctr">
+                  <a:tcPr anchor="ctr">
                     <a:lnL w="6350" cap="flat" cmpd="sng" algn="ctr">
                       <a:solidFill>
                         <a:srgbClr val="E2E8EC"/>
@@ -7360,6 +7358,11 @@
                     </a:solidFill>
                   </a:tcPr>
                 </a:tc>
+                <a:extLst>
+                  <a:ext uri="{0D108BD9-81ED-4DB2-BD59-A6C34878D82A}">
+                    <a16:rowId xmlns:a16="http://schemas.microsoft.com/office/drawing/2014/main" val="10001"/>
+                  </a:ext>
+                </a:extLst>
               </a:tr>
               <a:tr h="342900">
                 <a:tc>
@@ -7367,7 +7370,7 @@
                     <a:bodyPr/>
                     <a:lstStyle/>
                     <a:p>
-                      <a:pPr algn="l" indent="0" marL="0">
+                      <a:pPr marL="0" indent="0" algn="l">
                         <a:buNone/>
                       </a:pPr>
                       <a:r>
@@ -7388,7 +7391,7 @@
                       </a:endParaRPr>
                     </a:p>
                   </a:txBody>
-                  <a:tcPr marL="91440" marR="91440" marT="45720" marB="45720" anchor="ctr">
+                  <a:tcPr anchor="ctr">
                     <a:lnL w="6350" cap="flat" cmpd="sng" algn="ctr">
                       <a:solidFill>
                         <a:srgbClr val="E2E8EC"/>
@@ -7435,7 +7438,7 @@
                     <a:bodyPr/>
                     <a:lstStyle/>
                     <a:p>
-                      <a:pPr algn="r" indent="0" marL="0">
+                      <a:pPr marL="0" indent="0" algn="r">
                         <a:buNone/>
                       </a:pPr>
                       <a:r>
@@ -7456,7 +7459,7 @@
                       </a:endParaRPr>
                     </a:p>
                   </a:txBody>
-                  <a:tcPr marL="91440" marR="91440" marT="45720" marB="45720" anchor="ctr">
+                  <a:tcPr anchor="ctr">
                     <a:lnL w="6350" cap="flat" cmpd="sng" algn="ctr">
                       <a:solidFill>
                         <a:srgbClr val="E2E8EC"/>
@@ -7503,7 +7506,7 @@
                     <a:bodyPr/>
                     <a:lstStyle/>
                     <a:p>
-                      <a:pPr algn="r" indent="0" marL="0">
+                      <a:pPr marL="0" indent="0" algn="r">
                         <a:buNone/>
                       </a:pPr>
                       <a:r>
@@ -7524,7 +7527,7 @@
                       </a:endParaRPr>
                     </a:p>
                   </a:txBody>
-                  <a:tcPr marL="91440" marR="91440" marT="45720" marB="45720" anchor="ctr">
+                  <a:tcPr anchor="ctr">
                     <a:lnL w="6350" cap="flat" cmpd="sng" algn="ctr">
                       <a:solidFill>
                         <a:srgbClr val="E2E8EC"/>
@@ -7571,7 +7574,7 @@
                     <a:bodyPr/>
                     <a:lstStyle/>
                     <a:p>
-                      <a:pPr algn="r" indent="0" marL="0">
+                      <a:pPr marL="0" indent="0" algn="r">
                         <a:buNone/>
                       </a:pPr>
                       <a:r>
@@ -7592,7 +7595,7 @@
                       </a:endParaRPr>
                     </a:p>
                   </a:txBody>
-                  <a:tcPr marL="91440" marR="91440" marT="45720" marB="45720" anchor="ctr">
+                  <a:tcPr anchor="ctr">
                     <a:lnL w="6350" cap="flat" cmpd="sng" algn="ctr">
                       <a:solidFill>
                         <a:srgbClr val="E2E8EC"/>
@@ -7639,7 +7642,7 @@
                     <a:bodyPr/>
                     <a:lstStyle/>
                     <a:p>
-                      <a:pPr algn="r" indent="0" marL="0">
+                      <a:pPr marL="0" indent="0" algn="r">
                         <a:buNone/>
                       </a:pPr>
                       <a:r>
@@ -7660,7 +7663,7 @@
                       </a:endParaRPr>
                     </a:p>
                   </a:txBody>
-                  <a:tcPr marL="91440" marR="91440" marT="45720" marB="45720" anchor="ctr">
+                  <a:tcPr anchor="ctr">
                     <a:lnL w="6350" cap="flat" cmpd="sng" algn="ctr">
                       <a:solidFill>
                         <a:srgbClr val="E2E8EC"/>
@@ -7707,7 +7710,7 @@
                     <a:bodyPr/>
                     <a:lstStyle/>
                     <a:p>
-                      <a:pPr algn="l" indent="0" marL="0">
+                      <a:pPr marL="0" indent="0" algn="l">
                         <a:buNone/>
                       </a:pPr>
                       <a:r>
@@ -7728,7 +7731,7 @@
                       </a:endParaRPr>
                     </a:p>
                   </a:txBody>
-                  <a:tcPr marL="91440" marR="91440" marT="45720" marB="45720" anchor="ctr">
+                  <a:tcPr anchor="ctr">
                     <a:lnL w="6350" cap="flat" cmpd="sng" algn="ctr">
                       <a:solidFill>
                         <a:srgbClr val="E2E8EC"/>
@@ -7770,6 +7773,11 @@
                     </a:solidFill>
                   </a:tcPr>
                 </a:tc>
+                <a:extLst>
+                  <a:ext uri="{0D108BD9-81ED-4DB2-BD59-A6C34878D82A}">
+                    <a16:rowId xmlns:a16="http://schemas.microsoft.com/office/drawing/2014/main" val="10002"/>
+                  </a:ext>
+                </a:extLst>
               </a:tr>
               <a:tr h="342900">
                 <a:tc>
@@ -7777,7 +7785,7 @@
                     <a:bodyPr/>
                     <a:lstStyle/>
                     <a:p>
-                      <a:pPr algn="l" indent="0" marL="0">
+                      <a:pPr marL="0" indent="0" algn="l">
                         <a:buNone/>
                       </a:pPr>
                       <a:r>
@@ -7798,7 +7806,7 @@
                       </a:endParaRPr>
                     </a:p>
                   </a:txBody>
-                  <a:tcPr marL="91440" marR="91440" marT="45720" marB="45720" anchor="ctr">
+                  <a:tcPr anchor="ctr">
                     <a:lnL w="6350" cap="flat" cmpd="sng" algn="ctr">
                       <a:solidFill>
                         <a:srgbClr val="E2E8EC"/>
@@ -7845,7 +7853,7 @@
                     <a:bodyPr/>
                     <a:lstStyle/>
                     <a:p>
-                      <a:pPr algn="r" indent="0" marL="0">
+                      <a:pPr marL="0" indent="0" algn="r">
                         <a:buNone/>
                       </a:pPr>
                       <a:r>
@@ -7866,7 +7874,7 @@
                       </a:endParaRPr>
                     </a:p>
                   </a:txBody>
-                  <a:tcPr marL="91440" marR="91440" marT="45720" marB="45720" anchor="ctr">
+                  <a:tcPr anchor="ctr">
                     <a:lnL w="6350" cap="flat" cmpd="sng" algn="ctr">
                       <a:solidFill>
                         <a:srgbClr val="E2E8EC"/>
@@ -7913,7 +7921,7 @@
                     <a:bodyPr/>
                     <a:lstStyle/>
                     <a:p>
-                      <a:pPr algn="r" indent="0" marL="0">
+                      <a:pPr marL="0" indent="0" algn="r">
                         <a:buNone/>
                       </a:pPr>
                       <a:r>
@@ -7934,7 +7942,7 @@
                       </a:endParaRPr>
                     </a:p>
                   </a:txBody>
-                  <a:tcPr marL="91440" marR="91440" marT="45720" marB="45720" anchor="ctr">
+                  <a:tcPr anchor="ctr">
                     <a:lnL w="6350" cap="flat" cmpd="sng" algn="ctr">
                       <a:solidFill>
                         <a:srgbClr val="E2E8EC"/>
@@ -7981,7 +7989,7 @@
                     <a:bodyPr/>
                     <a:lstStyle/>
                     <a:p>
-                      <a:pPr algn="r" indent="0" marL="0">
+                      <a:pPr marL="0" indent="0" algn="r">
                         <a:buNone/>
                       </a:pPr>
                       <a:r>
@@ -8002,7 +8010,7 @@
                       </a:endParaRPr>
                     </a:p>
                   </a:txBody>
-                  <a:tcPr marL="91440" marR="91440" marT="45720" marB="45720" anchor="ctr">
+                  <a:tcPr anchor="ctr">
                     <a:lnL w="6350" cap="flat" cmpd="sng" algn="ctr">
                       <a:solidFill>
                         <a:srgbClr val="E2E8EC"/>
@@ -8049,7 +8057,7 @@
                     <a:bodyPr/>
                     <a:lstStyle/>
                     <a:p>
-                      <a:pPr algn="r" indent="0" marL="0">
+                      <a:pPr marL="0" indent="0" algn="r">
                         <a:buNone/>
                       </a:pPr>
                       <a:r>
@@ -8070,7 +8078,7 @@
                       </a:endParaRPr>
                     </a:p>
                   </a:txBody>
-                  <a:tcPr marL="91440" marR="91440" marT="45720" marB="45720" anchor="ctr">
+                  <a:tcPr anchor="ctr">
                     <a:lnL w="6350" cap="flat" cmpd="sng" algn="ctr">
                       <a:solidFill>
                         <a:srgbClr val="E2E8EC"/>
@@ -8117,7 +8125,7 @@
                     <a:bodyPr/>
                     <a:lstStyle/>
                     <a:p>
-                      <a:pPr algn="l" indent="0" marL="0">
+                      <a:pPr marL="0" indent="0" algn="l">
                         <a:buNone/>
                       </a:pPr>
                       <a:r>
@@ -8138,7 +8146,7 @@
                       </a:endParaRPr>
                     </a:p>
                   </a:txBody>
-                  <a:tcPr marL="91440" marR="91440" marT="45720" marB="45720" anchor="ctr">
+                  <a:tcPr anchor="ctr">
                     <a:lnL w="6350" cap="flat" cmpd="sng" algn="ctr">
                       <a:solidFill>
                         <a:srgbClr val="E2E8EC"/>
@@ -8180,6 +8188,11 @@
                     </a:solidFill>
                   </a:tcPr>
                 </a:tc>
+                <a:extLst>
+                  <a:ext uri="{0D108BD9-81ED-4DB2-BD59-A6C34878D82A}">
+                    <a16:rowId xmlns:a16="http://schemas.microsoft.com/office/drawing/2014/main" val="10003"/>
+                  </a:ext>
+                </a:extLst>
               </a:tr>
               <a:tr h="342900">
                 <a:tc>
@@ -8187,7 +8200,7 @@
                     <a:bodyPr/>
                     <a:lstStyle/>
                     <a:p>
-                      <a:pPr algn="l" indent="0" marL="0">
+                      <a:pPr marL="0" indent="0" algn="l">
                         <a:buNone/>
                       </a:pPr>
                       <a:r>
@@ -8208,7 +8221,7 @@
                       </a:endParaRPr>
                     </a:p>
                   </a:txBody>
-                  <a:tcPr marL="91440" marR="91440" marT="45720" marB="45720" anchor="ctr">
+                  <a:tcPr anchor="ctr">
                     <a:lnL w="6350" cap="flat" cmpd="sng" algn="ctr">
                       <a:solidFill>
                         <a:srgbClr val="E2E8EC"/>
@@ -8255,7 +8268,7 @@
                     <a:bodyPr/>
                     <a:lstStyle/>
                     <a:p>
-                      <a:pPr algn="r" indent="0" marL="0">
+                      <a:pPr marL="0" indent="0" algn="r">
                         <a:buNone/>
                       </a:pPr>
                       <a:r>
@@ -8276,7 +8289,7 @@
                       </a:endParaRPr>
                     </a:p>
                   </a:txBody>
-                  <a:tcPr marL="91440" marR="91440" marT="45720" marB="45720" anchor="ctr">
+                  <a:tcPr anchor="ctr">
                     <a:lnL w="6350" cap="flat" cmpd="sng" algn="ctr">
                       <a:solidFill>
                         <a:srgbClr val="E2E8EC"/>
@@ -8323,7 +8336,7 @@
                     <a:bodyPr/>
                     <a:lstStyle/>
                     <a:p>
-                      <a:pPr algn="r" indent="0" marL="0">
+                      <a:pPr marL="0" indent="0" algn="r">
                         <a:buNone/>
                       </a:pPr>
                       <a:r>
@@ -8344,7 +8357,7 @@
                       </a:endParaRPr>
                     </a:p>
                   </a:txBody>
-                  <a:tcPr marL="91440" marR="91440" marT="45720" marB="45720" anchor="ctr">
+                  <a:tcPr anchor="ctr">
                     <a:lnL w="6350" cap="flat" cmpd="sng" algn="ctr">
                       <a:solidFill>
                         <a:srgbClr val="E2E8EC"/>
@@ -8391,7 +8404,7 @@
                     <a:bodyPr/>
                     <a:lstStyle/>
                     <a:p>
-                      <a:pPr algn="r" indent="0" marL="0">
+                      <a:pPr marL="0" indent="0" algn="r">
                         <a:buNone/>
                       </a:pPr>
                       <a:r>
@@ -8412,7 +8425,7 @@
                       </a:endParaRPr>
                     </a:p>
                   </a:txBody>
-                  <a:tcPr marL="91440" marR="91440" marT="45720" marB="45720" anchor="ctr">
+                  <a:tcPr anchor="ctr">
                     <a:lnL w="6350" cap="flat" cmpd="sng" algn="ctr">
                       <a:solidFill>
                         <a:srgbClr val="E2E8EC"/>
@@ -8459,7 +8472,7 @@
                     <a:bodyPr/>
                     <a:lstStyle/>
                     <a:p>
-                      <a:pPr algn="r" indent="0" marL="0">
+                      <a:pPr marL="0" indent="0" algn="r">
                         <a:buNone/>
                       </a:pPr>
                       <a:r>
@@ -8480,7 +8493,7 @@
                       </a:endParaRPr>
                     </a:p>
                   </a:txBody>
-                  <a:tcPr marL="91440" marR="91440" marT="45720" marB="45720" anchor="ctr">
+                  <a:tcPr anchor="ctr">
                     <a:lnL w="6350" cap="flat" cmpd="sng" algn="ctr">
                       <a:solidFill>
                         <a:srgbClr val="E2E8EC"/>
@@ -8527,7 +8540,7 @@
                     <a:bodyPr/>
                     <a:lstStyle/>
                     <a:p>
-                      <a:pPr algn="l" indent="0" marL="0">
+                      <a:pPr marL="0" indent="0" algn="l">
                         <a:buNone/>
                       </a:pPr>
                       <a:r>
@@ -8548,7 +8561,7 @@
                       </a:endParaRPr>
                     </a:p>
                   </a:txBody>
-                  <a:tcPr marL="91440" marR="91440" marT="45720" marB="45720" anchor="ctr">
+                  <a:tcPr anchor="ctr">
                     <a:lnL w="6350" cap="flat" cmpd="sng" algn="ctr">
                       <a:solidFill>
                         <a:srgbClr val="E2E8EC"/>
@@ -8590,6 +8603,11 @@
                     </a:solidFill>
                   </a:tcPr>
                 </a:tc>
+                <a:extLst>
+                  <a:ext uri="{0D108BD9-81ED-4DB2-BD59-A6C34878D82A}">
+                    <a16:rowId xmlns:a16="http://schemas.microsoft.com/office/drawing/2014/main" val="10004"/>
+                  </a:ext>
+                </a:extLst>
               </a:tr>
               <a:tr h="342900">
                 <a:tc>
@@ -8597,7 +8615,7 @@
                     <a:bodyPr/>
                     <a:lstStyle/>
                     <a:p>
-                      <a:pPr algn="l" indent="0" marL="0">
+                      <a:pPr marL="0" indent="0" algn="l">
                         <a:buNone/>
                       </a:pPr>
                       <a:r>
@@ -8618,7 +8636,7 @@
                       </a:endParaRPr>
                     </a:p>
                   </a:txBody>
-                  <a:tcPr marL="91440" marR="91440" marT="45720" marB="45720" anchor="ctr">
+                  <a:tcPr anchor="ctr">
                     <a:lnL w="6350" cap="flat" cmpd="sng" algn="ctr">
                       <a:solidFill>
                         <a:srgbClr val="E2E8EC"/>
@@ -8665,7 +8683,7 @@
                     <a:bodyPr/>
                     <a:lstStyle/>
                     <a:p>
-                      <a:pPr algn="r" indent="0" marL="0">
+                      <a:pPr marL="0" indent="0" algn="r">
                         <a:buNone/>
                       </a:pPr>
                       <a:r>
@@ -8686,7 +8704,7 @@
                       </a:endParaRPr>
                     </a:p>
                   </a:txBody>
-                  <a:tcPr marL="91440" marR="91440" marT="45720" marB="45720" anchor="ctr">
+                  <a:tcPr anchor="ctr">
                     <a:lnL w="6350" cap="flat" cmpd="sng" algn="ctr">
                       <a:solidFill>
                         <a:srgbClr val="E2E8EC"/>
@@ -8733,7 +8751,7 @@
                     <a:bodyPr/>
                     <a:lstStyle/>
                     <a:p>
-                      <a:pPr algn="r" indent="0" marL="0">
+                      <a:pPr marL="0" indent="0" algn="r">
                         <a:buNone/>
                       </a:pPr>
                       <a:r>
@@ -8754,7 +8772,7 @@
                       </a:endParaRPr>
                     </a:p>
                   </a:txBody>
-                  <a:tcPr marL="91440" marR="91440" marT="45720" marB="45720" anchor="ctr">
+                  <a:tcPr anchor="ctr">
                     <a:lnL w="6350" cap="flat" cmpd="sng" algn="ctr">
                       <a:solidFill>
                         <a:srgbClr val="E2E8EC"/>
@@ -8801,7 +8819,7 @@
                     <a:bodyPr/>
                     <a:lstStyle/>
                     <a:p>
-                      <a:pPr algn="r" indent="0" marL="0">
+                      <a:pPr marL="0" indent="0" algn="r">
                         <a:buNone/>
                       </a:pPr>
                       <a:r>
@@ -8822,7 +8840,7 @@
                       </a:endParaRPr>
                     </a:p>
                   </a:txBody>
-                  <a:tcPr marL="91440" marR="91440" marT="45720" marB="45720" anchor="ctr">
+                  <a:tcPr anchor="ctr">
                     <a:lnL w="6350" cap="flat" cmpd="sng" algn="ctr">
                       <a:solidFill>
                         <a:srgbClr val="E2E8EC"/>
@@ -8869,7 +8887,7 @@
                     <a:bodyPr/>
                     <a:lstStyle/>
                     <a:p>
-                      <a:pPr algn="r" indent="0" marL="0">
+                      <a:pPr marL="0" indent="0" algn="r">
                         <a:buNone/>
                       </a:pPr>
                       <a:r>
@@ -8890,7 +8908,7 @@
                       </a:endParaRPr>
                     </a:p>
                   </a:txBody>
-                  <a:tcPr marL="91440" marR="91440" marT="45720" marB="45720" anchor="ctr">
+                  <a:tcPr anchor="ctr">
                     <a:lnL w="6350" cap="flat" cmpd="sng" algn="ctr">
                       <a:solidFill>
                         <a:srgbClr val="E2E8EC"/>
@@ -8937,7 +8955,7 @@
                     <a:bodyPr/>
                     <a:lstStyle/>
                     <a:p>
-                      <a:pPr algn="l" indent="0" marL="0">
+                      <a:pPr marL="0" indent="0" algn="l">
                         <a:buNone/>
                       </a:pPr>
                       <a:r>
@@ -8958,7 +8976,7 @@
                       </a:endParaRPr>
                     </a:p>
                   </a:txBody>
-                  <a:tcPr marL="91440" marR="91440" marT="45720" marB="45720" anchor="ctr">
+                  <a:tcPr anchor="ctr">
                     <a:lnL w="6350" cap="flat" cmpd="sng" algn="ctr">
                       <a:solidFill>
                         <a:srgbClr val="E2E8EC"/>
@@ -9000,6 +9018,11 @@
                     </a:solidFill>
                   </a:tcPr>
                 </a:tc>
+                <a:extLst>
+                  <a:ext uri="{0D108BD9-81ED-4DB2-BD59-A6C34878D82A}">
+                    <a16:rowId xmlns:a16="http://schemas.microsoft.com/office/drawing/2014/main" val="10005"/>
+                  </a:ext>
+                </a:extLst>
               </a:tr>
               <a:tr h="342900">
                 <a:tc>
@@ -9007,7 +9030,7 @@
                     <a:bodyPr/>
                     <a:lstStyle/>
                     <a:p>
-                      <a:pPr algn="l" indent="0" marL="0">
+                      <a:pPr marL="0" indent="0" algn="l">
                         <a:buNone/>
                       </a:pPr>
                       <a:r>
@@ -9028,7 +9051,7 @@
                       </a:endParaRPr>
                     </a:p>
                   </a:txBody>
-                  <a:tcPr marL="91440" marR="91440" marT="45720" marB="45720" anchor="ctr">
+                  <a:tcPr anchor="ctr">
                     <a:lnL w="6350" cap="flat" cmpd="sng" algn="ctr">
                       <a:solidFill>
                         <a:srgbClr val="E2E8EC"/>
@@ -9075,7 +9098,7 @@
                     <a:bodyPr/>
                     <a:lstStyle/>
                     <a:p>
-                      <a:pPr algn="r" indent="0" marL="0">
+                      <a:pPr marL="0" indent="0" algn="r">
                         <a:buNone/>
                       </a:pPr>
                       <a:r>
@@ -9096,7 +9119,7 @@
                       </a:endParaRPr>
                     </a:p>
                   </a:txBody>
-                  <a:tcPr marL="91440" marR="91440" marT="45720" marB="45720" anchor="ctr">
+                  <a:tcPr anchor="ctr">
                     <a:lnL w="6350" cap="flat" cmpd="sng" algn="ctr">
                       <a:solidFill>
                         <a:srgbClr val="E2E8EC"/>
@@ -9143,7 +9166,7 @@
                     <a:bodyPr/>
                     <a:lstStyle/>
                     <a:p>
-                      <a:pPr algn="r" indent="0" marL="0">
+                      <a:pPr marL="0" indent="0" algn="r">
                         <a:buNone/>
                       </a:pPr>
                       <a:r>
@@ -9164,7 +9187,7 @@
                       </a:endParaRPr>
                     </a:p>
                   </a:txBody>
-                  <a:tcPr marL="91440" marR="91440" marT="45720" marB="45720" anchor="ctr">
+                  <a:tcPr anchor="ctr">
                     <a:lnL w="6350" cap="flat" cmpd="sng" algn="ctr">
                       <a:solidFill>
                         <a:srgbClr val="E2E8EC"/>
@@ -9211,7 +9234,7 @@
                     <a:bodyPr/>
                     <a:lstStyle/>
                     <a:p>
-                      <a:pPr algn="r" indent="0" marL="0">
+                      <a:pPr marL="0" indent="0" algn="r">
                         <a:buNone/>
                       </a:pPr>
                       <a:r>
@@ -9232,7 +9255,7 @@
                       </a:endParaRPr>
                     </a:p>
                   </a:txBody>
-                  <a:tcPr marL="91440" marR="91440" marT="45720" marB="45720" anchor="ctr">
+                  <a:tcPr anchor="ctr">
                     <a:lnL w="6350" cap="flat" cmpd="sng" algn="ctr">
                       <a:solidFill>
                         <a:srgbClr val="E2E8EC"/>
@@ -9279,7 +9302,7 @@
                     <a:bodyPr/>
                     <a:lstStyle/>
                     <a:p>
-                      <a:pPr algn="r" indent="0" marL="0">
+                      <a:pPr marL="0" indent="0" algn="r">
                         <a:buNone/>
                       </a:pPr>
                       <a:r>
@@ -9300,7 +9323,7 @@
                       </a:endParaRPr>
                     </a:p>
                   </a:txBody>
-                  <a:tcPr marL="91440" marR="91440" marT="45720" marB="45720" anchor="ctr">
+                  <a:tcPr anchor="ctr">
                     <a:lnL w="6350" cap="flat" cmpd="sng" algn="ctr">
                       <a:solidFill>
                         <a:srgbClr val="E2E8EC"/>
@@ -9347,7 +9370,7 @@
                     <a:bodyPr/>
                     <a:lstStyle/>
                     <a:p>
-                      <a:pPr algn="l" indent="0" marL="0">
+                      <a:pPr marL="0" indent="0" algn="l">
                         <a:buNone/>
                       </a:pPr>
                       <a:r>
@@ -9368,7 +9391,7 @@
                       </a:endParaRPr>
                     </a:p>
                   </a:txBody>
-                  <a:tcPr marL="91440" marR="91440" marT="45720" marB="45720" anchor="ctr">
+                  <a:tcPr anchor="ctr">
                     <a:lnL w="6350" cap="flat" cmpd="sng" algn="ctr">
                       <a:solidFill>
                         <a:srgbClr val="E2E8EC"/>
@@ -9410,6 +9433,11 @@
                     </a:solidFill>
                   </a:tcPr>
                 </a:tc>
+                <a:extLst>
+                  <a:ext uri="{0D108BD9-81ED-4DB2-BD59-A6C34878D82A}">
+                    <a16:rowId xmlns:a16="http://schemas.microsoft.com/office/drawing/2014/main" val="10006"/>
+                  </a:ext>
+                </a:extLst>
               </a:tr>
             </a:tbl>
           </a:graphicData>
@@ -9417,7 +9445,7 @@
       </p:graphicFrame>
       <p:sp>
         <p:nvSpPr>
-          <p:cNvPr id="6" name="Shape 3"/>
+          <p:cNvPr id="5" name="Shape 3"/>
           <p:cNvSpPr/>
           <p:nvPr/>
         </p:nvSpPr>
@@ -9436,6 +9464,13 @@
           </a:solidFill>
           <a:ln/>
         </p:spPr>
+        <p:txBody>
+          <a:bodyPr/>
+          <a:lstStyle/>
+          <a:p>
+            <a:endParaRPr lang="it-IT"/>
+          </a:p>
+        </p:txBody>
       </p:sp>
       <p:sp>
         <p:nvSpPr>
@@ -9458,7 +9493,7 @@
           <a:bodyPr wrap="square" lIns="0" tIns="0" rIns="0" bIns="0" rtlCol="0" anchor="ctr"/>
           <a:lstStyle/>
           <a:p>
-            <a:pPr indent="0" marL="0">
+            <a:pPr marL="0" indent="0">
               <a:buNone/>
             </a:pPr>
             <a:r>
@@ -9497,7 +9532,7 @@
           <a:bodyPr wrap="square" lIns="0" tIns="0" rIns="0" bIns="0" rtlCol="0" anchor="ctr"/>
           <a:lstStyle/>
           <a:p>
-            <a:pPr indent="0" marL="0">
+            <a:pPr marL="0" indent="0">
               <a:lnSpc>
                 <a:spcPts val="1500"/>
               </a:lnSpc>
@@ -9518,7 +9553,7 @@
             <a:endParaRPr lang="en-US" sz="1150" dirty="0"/>
           </a:p>
           <a:p>
-            <a:pPr indent="0" marL="0">
+            <a:pPr marL="0" indent="0">
               <a:lnSpc>
                 <a:spcPts val="1500"/>
               </a:lnSpc>
@@ -9539,7 +9574,7 @@
             <a:endParaRPr lang="en-US" sz="1150" dirty="0"/>
           </a:p>
           <a:p>
-            <a:pPr indent="0" marL="0">
+            <a:pPr marL="0" indent="0">
               <a:lnSpc>
                 <a:spcPts val="1500"/>
               </a:lnSpc>
@@ -9581,7 +9616,7 @@
           <a:bodyPr wrap="square" lIns="0" tIns="0" rIns="0" bIns="0" rtlCol="0" anchor="ctr"/>
           <a:lstStyle/>
           <a:p>
-            <a:pPr indent="0" marL="0">
+            <a:pPr marL="0" indent="0">
               <a:buNone/>
             </a:pPr>
             <a:r>
@@ -9645,11 +9680,11 @@
           <a:bodyPr wrap="square" lIns="0" tIns="0" rIns="0" bIns="0" rtlCol="0" anchor="ctr"/>
           <a:lstStyle/>
           <a:p>
-            <a:pPr indent="0" marL="0">
+            <a:pPr marL="0" indent="0">
               <a:buNone/>
             </a:pPr>
             <a:r>
-              <a:rPr lang="en-US" sz="1200" b="1" spc="200" kern="0" dirty="0">
+              <a:rPr lang="en-US" sz="1200" b="1" kern="0" spc="200" dirty="0">
                 <a:solidFill>
                   <a:srgbClr val="EB6834"/>
                 </a:solidFill>
@@ -9684,7 +9719,7 @@
           <a:bodyPr wrap="square" lIns="0" tIns="0" rIns="0" bIns="0" rtlCol="0" anchor="ctr"/>
           <a:lstStyle/>
           <a:p>
-            <a:pPr indent="0" marL="0">
+            <a:pPr marL="0" indent="0">
               <a:buNone/>
             </a:pPr>
             <a:r>
@@ -9704,14 +9739,14 @@
       </p:sp>
       <p:pic>
         <p:nvPicPr>
-          <p:cNvPr id="4" name="Image 0" descr="C:\Users\Unipa\Documents\MaltaDT\figures\domain_design.png">    </p:cNvPr>
+          <p:cNvPr id="4" name="Image 0" descr="C:\Users\Unipa\Documents\MaltaDT\figures\domain_design.png"/>
           <p:cNvPicPr>
             <a:picLocks noChangeAspect="1"/>
           </p:cNvPicPr>
           <p:nvPr/>
         </p:nvPicPr>
         <p:blipFill>
-          <a:blip r:embed="rId1"/>
+          <a:blip r:embed="rId3"/>
           <a:stretch>
             <a:fillRect/>
           </a:stretch>
@@ -9772,11 +9807,11 @@
           <a:bodyPr wrap="square" lIns="0" tIns="0" rIns="0" bIns="0" rtlCol="0" anchor="ctr"/>
           <a:lstStyle/>
           <a:p>
-            <a:pPr indent="0" marL="0">
+            <a:pPr marL="0" indent="0">
               <a:buNone/>
             </a:pPr>
             <a:r>
-              <a:rPr lang="en-US" sz="1200" b="1" spc="200" kern="0" dirty="0">
+              <a:rPr lang="en-US" sz="1200" b="1" kern="0" spc="200" dirty="0">
                 <a:solidFill>
                   <a:srgbClr val="EB6834"/>
                 </a:solidFill>
@@ -9811,7 +9846,7 @@
           <a:bodyPr wrap="square" lIns="0" tIns="0" rIns="0" bIns="0" rtlCol="0" anchor="ctr"/>
           <a:lstStyle/>
           <a:p>
-            <a:pPr indent="0" marL="0">
+            <a:pPr marL="0" indent="0">
               <a:buNone/>
             </a:pPr>
             <a:r>
@@ -9850,7 +9885,7 @@
           <a:bodyPr wrap="square" lIns="0" tIns="0" rIns="0" bIns="0" rtlCol="0" anchor="ctr"/>
           <a:lstStyle/>
           <a:p>
-            <a:pPr indent="0" marL="0">
+            <a:pPr marL="0" indent="0">
               <a:buNone/>
             </a:pPr>
             <a:r>
@@ -9889,7 +9924,7 @@
           <a:bodyPr wrap="square" lIns="0" tIns="0" rIns="0" bIns="0" rtlCol="0" anchor="ctr"/>
           <a:lstStyle/>
           <a:p>
-            <a:pPr indent="0" marL="0">
+            <a:pPr marL="0" indent="0">
               <a:buNone/>
             </a:pPr>
             <a:r>
@@ -9928,7 +9963,7 @@
           <a:bodyPr wrap="square" lIns="0" tIns="0" rIns="0" bIns="0" rtlCol="0" anchor="ctr"/>
           <a:lstStyle/>
           <a:p>
-            <a:pPr indent="0" marL="0">
+            <a:pPr marL="0" indent="0">
               <a:lnSpc>
                 <a:spcPts val="1700"/>
               </a:lnSpc>
@@ -9952,7 +9987,7 @@
             <a:endParaRPr lang="en-US" sz="1250" dirty="0"/>
           </a:p>
           <a:p>
-            <a:pPr indent="0" marL="0">
+            <a:pPr marL="0" indent="0">
               <a:lnSpc>
                 <a:spcPts val="1700"/>
               </a:lnSpc>
@@ -9989,15 +10024,27 @@
         </p:nvGraphicFramePr>
         <p:xfrm>
           <a:off x="566928" y="3456432"/>
-          <a:ext cx="4937760" cy="914400"/>
+          <a:ext cx="4937760" cy="2057400"/>
         </p:xfrm>
         <a:graphic>
           <a:graphicData uri="http://schemas.openxmlformats.org/drawingml/2006/table">
             <a:tbl>
               <a:tblPr/>
               <a:tblGrid>
-                <a:gridCol w="3291840"/>
-                <a:gridCol w="1645920"/>
+                <a:gridCol w="3291840">
+                  <a:extLst>
+                    <a:ext uri="{9D8B030D-6E8A-4147-A177-3AD203B41FA5}">
+                      <a16:colId xmlns:a16="http://schemas.microsoft.com/office/drawing/2014/main" val="20000"/>
+                    </a:ext>
+                  </a:extLst>
+                </a:gridCol>
+                <a:gridCol w="1645920">
+                  <a:extLst>
+                    <a:ext uri="{9D8B030D-6E8A-4147-A177-3AD203B41FA5}">
+                      <a16:colId xmlns:a16="http://schemas.microsoft.com/office/drawing/2014/main" val="20001"/>
+                    </a:ext>
+                  </a:extLst>
+                </a:gridCol>
               </a:tblGrid>
               <a:tr h="342900">
                 <a:tc>
@@ -10005,7 +10052,7 @@
                     <a:bodyPr/>
                     <a:lstStyle/>
                     <a:p>
-                      <a:pPr algn="l" indent="0" marL="0">
+                      <a:pPr marL="0" indent="0" algn="l">
                         <a:buNone/>
                       </a:pPr>
                       <a:r>
@@ -10026,7 +10073,7 @@
                       </a:endParaRPr>
                     </a:p>
                   </a:txBody>
-                  <a:tcPr marL="91440" marR="91440" marT="45720" marB="45720" anchor="ctr">
+                  <a:tcPr anchor="ctr">
                     <a:lnL w="6350" cap="flat" cmpd="sng" algn="ctr">
                       <a:solidFill>
                         <a:srgbClr val="E2E8EC"/>
@@ -10073,7 +10120,7 @@
                     <a:bodyPr/>
                     <a:lstStyle/>
                     <a:p>
-                      <a:pPr algn="r" indent="0" marL="0">
+                      <a:pPr marL="0" indent="0" algn="r">
                         <a:buNone/>
                       </a:pPr>
                       <a:r>
@@ -10094,7 +10141,7 @@
                       </a:endParaRPr>
                     </a:p>
                   </a:txBody>
-                  <a:tcPr marL="91440" marR="91440" marT="45720" marB="45720" anchor="ctr">
+                  <a:tcPr anchor="ctr">
                     <a:lnL w="6350" cap="flat" cmpd="sng" algn="ctr">
                       <a:solidFill>
                         <a:srgbClr val="E2E8EC"/>
@@ -10136,6 +10183,11 @@
                     </a:solidFill>
                   </a:tcPr>
                 </a:tc>
+                <a:extLst>
+                  <a:ext uri="{0D108BD9-81ED-4DB2-BD59-A6C34878D82A}">
+                    <a16:rowId xmlns:a16="http://schemas.microsoft.com/office/drawing/2014/main" val="10000"/>
+                  </a:ext>
+                </a:extLst>
               </a:tr>
               <a:tr h="342900">
                 <a:tc>
@@ -10143,7 +10195,7 @@
                     <a:bodyPr/>
                     <a:lstStyle/>
                     <a:p>
-                      <a:pPr algn="l" indent="0" marL="0">
+                      <a:pPr marL="0" indent="0" algn="l">
                         <a:buNone/>
                       </a:pPr>
                       <a:r>
@@ -10164,7 +10216,7 @@
                       </a:endParaRPr>
                     </a:p>
                   </a:txBody>
-                  <a:tcPr marL="91440" marR="91440" marT="45720" marB="45720" anchor="ctr">
+                  <a:tcPr anchor="ctr">
                     <a:lnL w="6350" cap="flat" cmpd="sng" algn="ctr">
                       <a:solidFill>
                         <a:srgbClr val="E2E8EC"/>
@@ -10211,7 +10263,7 @@
                     <a:bodyPr/>
                     <a:lstStyle/>
                     <a:p>
-                      <a:pPr algn="r" indent="0" marL="0">
+                      <a:pPr marL="0" indent="0" algn="r">
                         <a:buNone/>
                       </a:pPr>
                       <a:r>
@@ -10232,7 +10284,7 @@
                       </a:endParaRPr>
                     </a:p>
                   </a:txBody>
-                  <a:tcPr marL="91440" marR="91440" marT="45720" marB="45720" anchor="ctr">
+                  <a:tcPr anchor="ctr">
                     <a:lnL w="6350" cap="flat" cmpd="sng" algn="ctr">
                       <a:solidFill>
                         <a:srgbClr val="E2E8EC"/>
@@ -10274,6 +10326,11 @@
                     </a:solidFill>
                   </a:tcPr>
                 </a:tc>
+                <a:extLst>
+                  <a:ext uri="{0D108BD9-81ED-4DB2-BD59-A6C34878D82A}">
+                    <a16:rowId xmlns:a16="http://schemas.microsoft.com/office/drawing/2014/main" val="10001"/>
+                  </a:ext>
+                </a:extLst>
               </a:tr>
               <a:tr h="342900">
                 <a:tc>
@@ -10281,7 +10338,7 @@
                     <a:bodyPr/>
                     <a:lstStyle/>
                     <a:p>
-                      <a:pPr algn="l" indent="0" marL="0">
+                      <a:pPr marL="0" indent="0" algn="l">
                         <a:buNone/>
                       </a:pPr>
                       <a:r>
@@ -10302,7 +10359,7 @@
                       </a:endParaRPr>
                     </a:p>
                   </a:txBody>
-                  <a:tcPr marL="91440" marR="91440" marT="45720" marB="45720" anchor="ctr">
+                  <a:tcPr anchor="ctr">
                     <a:lnL w="6350" cap="flat" cmpd="sng" algn="ctr">
                       <a:solidFill>
                         <a:srgbClr val="E2E8EC"/>
@@ -10349,7 +10406,7 @@
                     <a:bodyPr/>
                     <a:lstStyle/>
                     <a:p>
-                      <a:pPr algn="r" indent="0" marL="0">
+                      <a:pPr marL="0" indent="0" algn="r">
                         <a:buNone/>
                       </a:pPr>
                       <a:r>
@@ -10370,7 +10427,7 @@
                       </a:endParaRPr>
                     </a:p>
                   </a:txBody>
-                  <a:tcPr marL="91440" marR="91440" marT="45720" marB="45720" anchor="ctr">
+                  <a:tcPr anchor="ctr">
                     <a:lnL w="6350" cap="flat" cmpd="sng" algn="ctr">
                       <a:solidFill>
                         <a:srgbClr val="E2E8EC"/>
@@ -10412,6 +10469,11 @@
                     </a:solidFill>
                   </a:tcPr>
                 </a:tc>
+                <a:extLst>
+                  <a:ext uri="{0D108BD9-81ED-4DB2-BD59-A6C34878D82A}">
+                    <a16:rowId xmlns:a16="http://schemas.microsoft.com/office/drawing/2014/main" val="10002"/>
+                  </a:ext>
+                </a:extLst>
               </a:tr>
               <a:tr h="342900">
                 <a:tc>
@@ -10419,7 +10481,7 @@
                     <a:bodyPr/>
                     <a:lstStyle/>
                     <a:p>
-                      <a:pPr algn="l" indent="0" marL="0">
+                      <a:pPr marL="0" indent="0" algn="l">
                         <a:buNone/>
                       </a:pPr>
                       <a:r>
@@ -10440,7 +10502,7 @@
                       </a:endParaRPr>
                     </a:p>
                   </a:txBody>
-                  <a:tcPr marL="91440" marR="91440" marT="45720" marB="45720" anchor="ctr">
+                  <a:tcPr anchor="ctr">
                     <a:lnL w="6350" cap="flat" cmpd="sng" algn="ctr">
                       <a:solidFill>
                         <a:srgbClr val="E2E8EC"/>
@@ -10487,7 +10549,7 @@
                     <a:bodyPr/>
                     <a:lstStyle/>
                     <a:p>
-                      <a:pPr algn="r" indent="0" marL="0">
+                      <a:pPr marL="0" indent="0" algn="r">
                         <a:buNone/>
                       </a:pPr>
                       <a:r>
@@ -10508,7 +10570,7 @@
                       </a:endParaRPr>
                     </a:p>
                   </a:txBody>
-                  <a:tcPr marL="91440" marR="91440" marT="45720" marB="45720" anchor="ctr">
+                  <a:tcPr anchor="ctr">
                     <a:lnL w="6350" cap="flat" cmpd="sng" algn="ctr">
                       <a:solidFill>
                         <a:srgbClr val="E2E8EC"/>
@@ -10550,6 +10612,11 @@
                     </a:solidFill>
                   </a:tcPr>
                 </a:tc>
+                <a:extLst>
+                  <a:ext uri="{0D108BD9-81ED-4DB2-BD59-A6C34878D82A}">
+                    <a16:rowId xmlns:a16="http://schemas.microsoft.com/office/drawing/2014/main" val="10003"/>
+                  </a:ext>
+                </a:extLst>
               </a:tr>
               <a:tr h="342900">
                 <a:tc>
@@ -10557,7 +10624,7 @@
                     <a:bodyPr/>
                     <a:lstStyle/>
                     <a:p>
-                      <a:pPr algn="l" indent="0" marL="0">
+                      <a:pPr marL="0" indent="0" algn="l">
                         <a:buNone/>
                       </a:pPr>
                       <a:r>
@@ -10578,7 +10645,7 @@
                       </a:endParaRPr>
                     </a:p>
                   </a:txBody>
-                  <a:tcPr marL="91440" marR="91440" marT="45720" marB="45720" anchor="ctr">
+                  <a:tcPr anchor="ctr">
                     <a:lnL w="6350" cap="flat" cmpd="sng" algn="ctr">
                       <a:solidFill>
                         <a:srgbClr val="E2E8EC"/>
@@ -10625,7 +10692,7 @@
                     <a:bodyPr/>
                     <a:lstStyle/>
                     <a:p>
-                      <a:pPr algn="r" indent="0" marL="0">
+                      <a:pPr marL="0" indent="0" algn="r">
                         <a:buNone/>
                       </a:pPr>
                       <a:r>
@@ -10646,7 +10713,7 @@
                       </a:endParaRPr>
                     </a:p>
                   </a:txBody>
-                  <a:tcPr marL="91440" marR="91440" marT="45720" marB="45720" anchor="ctr">
+                  <a:tcPr anchor="ctr">
                     <a:lnL w="6350" cap="flat" cmpd="sng" algn="ctr">
                       <a:solidFill>
                         <a:srgbClr val="E2E8EC"/>
@@ -10688,6 +10755,11 @@
                     </a:solidFill>
                   </a:tcPr>
                 </a:tc>
+                <a:extLst>
+                  <a:ext uri="{0D108BD9-81ED-4DB2-BD59-A6C34878D82A}">
+                    <a16:rowId xmlns:a16="http://schemas.microsoft.com/office/drawing/2014/main" val="10004"/>
+                  </a:ext>
+                </a:extLst>
               </a:tr>
               <a:tr h="342900">
                 <a:tc>
@@ -10695,7 +10767,7 @@
                     <a:bodyPr/>
                     <a:lstStyle/>
                     <a:p>
-                      <a:pPr algn="l" indent="0" marL="0">
+                      <a:pPr marL="0" indent="0" algn="l">
                         <a:buNone/>
                       </a:pPr>
                       <a:r>
@@ -10716,7 +10788,7 @@
                       </a:endParaRPr>
                     </a:p>
                   </a:txBody>
-                  <a:tcPr marL="91440" marR="91440" marT="45720" marB="45720" anchor="ctr">
+                  <a:tcPr anchor="ctr">
                     <a:lnL w="6350" cap="flat" cmpd="sng" algn="ctr">
                       <a:solidFill>
                         <a:srgbClr val="E2E8EC"/>
@@ -10763,7 +10835,7 @@
                     <a:bodyPr/>
                     <a:lstStyle/>
                     <a:p>
-                      <a:pPr algn="r" indent="0" marL="0">
+                      <a:pPr marL="0" indent="0" algn="r">
                         <a:buNone/>
                       </a:pPr>
                       <a:r>
@@ -10784,7 +10856,7 @@
                       </a:endParaRPr>
                     </a:p>
                   </a:txBody>
-                  <a:tcPr marL="91440" marR="91440" marT="45720" marB="45720" anchor="ctr">
+                  <a:tcPr anchor="ctr">
                     <a:lnL w="6350" cap="flat" cmpd="sng" algn="ctr">
                       <a:solidFill>
                         <a:srgbClr val="E2E8EC"/>
@@ -10826,6 +10898,11 @@
                     </a:solidFill>
                   </a:tcPr>
                 </a:tc>
+                <a:extLst>
+                  <a:ext uri="{0D108BD9-81ED-4DB2-BD59-A6C34878D82A}">
+                    <a16:rowId xmlns:a16="http://schemas.microsoft.com/office/drawing/2014/main" val="10005"/>
+                  </a:ext>
+                </a:extLst>
               </a:tr>
             </a:tbl>
           </a:graphicData>
@@ -10833,7 +10910,7 @@
       </p:graphicFrame>
       <p:sp>
         <p:nvSpPr>
-          <p:cNvPr id="8" name="Shape 5"/>
+          <p:cNvPr id="7" name="Shape 5"/>
           <p:cNvSpPr/>
           <p:nvPr/>
         </p:nvSpPr>
@@ -10852,6 +10929,13 @@
           </a:solidFill>
           <a:ln/>
         </p:spPr>
+        <p:txBody>
+          <a:bodyPr/>
+          <a:lstStyle/>
+          <a:p>
+            <a:endParaRPr lang="it-IT"/>
+          </a:p>
+        </p:txBody>
       </p:sp>
       <p:sp>
         <p:nvSpPr>
@@ -10874,7 +10958,7 @@
           <a:bodyPr wrap="square" lIns="0" tIns="0" rIns="0" bIns="0" rtlCol="0" anchor="ctr"/>
           <a:lstStyle/>
           <a:p>
-            <a:pPr indent="0" marL="0">
+            <a:pPr marL="0" indent="0">
               <a:buNone/>
             </a:pPr>
             <a:r>
@@ -10913,7 +10997,7 @@
           <a:bodyPr wrap="square" lIns="0" tIns="0" rIns="0" bIns="0" rtlCol="0" anchor="ctr"/>
           <a:lstStyle/>
           <a:p>
-            <a:pPr indent="0" marL="0">
+            <a:pPr marL="0" indent="0">
               <a:lnSpc>
                 <a:spcPts val="1600"/>
               </a:lnSpc>
@@ -10955,6 +11039,13 @@
           </a:solidFill>
           <a:ln/>
         </p:spPr>
+        <p:txBody>
+          <a:bodyPr/>
+          <a:lstStyle/>
+          <a:p>
+            <a:endParaRPr lang="it-IT"/>
+          </a:p>
+        </p:txBody>
       </p:sp>
       <p:sp>
         <p:nvSpPr>
@@ -10977,7 +11068,7 @@
           <a:bodyPr wrap="square" lIns="0" tIns="0" rIns="0" bIns="0" rtlCol="0" anchor="ctr"/>
           <a:lstStyle/>
           <a:p>
-            <a:pPr indent="0" marL="0">
+            <a:pPr marL="0" indent="0">
               <a:buNone/>
             </a:pPr>
             <a:r>
@@ -11016,7 +11107,7 @@
           <a:bodyPr wrap="square" lIns="0" tIns="0" rIns="0" bIns="0" rtlCol="0" anchor="ctr"/>
           <a:lstStyle/>
           <a:p>
-            <a:pPr indent="0" marL="0">
+            <a:pPr marL="0" indent="0">
               <a:lnSpc>
                 <a:spcPts val="1600"/>
               </a:lnSpc>
@@ -11037,7 +11128,7 @@
             <a:endParaRPr lang="en-US" sz="1200" dirty="0"/>
           </a:p>
           <a:p>
-            <a:pPr indent="0" marL="0">
+            <a:pPr marL="0" indent="0">
               <a:lnSpc>
                 <a:spcPts val="1600"/>
               </a:lnSpc>
@@ -11104,11 +11195,11 @@
           <a:bodyPr wrap="square" lIns="0" tIns="0" rIns="0" bIns="0" rtlCol="0" anchor="ctr"/>
           <a:lstStyle/>
           <a:p>
-            <a:pPr indent="0" marL="0">
+            <a:pPr marL="0" indent="0">
               <a:buNone/>
             </a:pPr>
             <a:r>
-              <a:rPr lang="en-US" sz="1200" b="1" spc="200" kern="0" dirty="0">
+              <a:rPr lang="en-US" sz="1200" b="1" kern="0" spc="200" dirty="0">
                 <a:solidFill>
                   <a:srgbClr val="EB6834"/>
                 </a:solidFill>
@@ -11143,7 +11234,7 @@
           <a:bodyPr wrap="square" lIns="0" tIns="0" rIns="0" bIns="0" rtlCol="0" anchor="ctr"/>
           <a:lstStyle/>
           <a:p>
-            <a:pPr indent="0" marL="0">
+            <a:pPr marL="0" indent="0">
               <a:buNone/>
             </a:pPr>
             <a:r>
@@ -11155,48 +11246,8 @@
                 <a:ea typeface="Cambria" pitchFamily="34" charset="-122"/>
                 <a:cs typeface="Cambria" pitchFamily="34" charset="-120"/>
               </a:rPr>
-              <a:t>A proposed question, for the group to judge</a:t>
-            </a:r>
-            <a:endParaRPr lang="en-US" sz="3200" dirty="0"/>
-          </a:p>
-        </p:txBody>
-      </p:sp>
-      <p:sp>
-        <p:nvSpPr>
-          <p:cNvPr id="4" name="Text 2"/>
-          <p:cNvSpPr txBox="1"/>
-          <p:nvPr/>
-        </p:nvSpPr>
-        <p:spPr>
-          <a:xfrm>
-            <a:off x="566928" y="1408176"/>
-            <a:ext cx="10881360" cy="585216"/>
-          </a:xfrm>
-          <a:prstGeom prst="rect">
-            <a:avLst/>
-          </a:prstGeom>
-          <a:noFill/>
-          <a:ln/>
-        </p:spPr>
-        <p:txBody>
-          <a:bodyPr wrap="square" lIns="0" tIns="0" rIns="0" bIns="0" rtlCol="0" anchor="ctr"/>
-          <a:lstStyle/>
-          <a:p>
-            <a:pPr indent="0" marL="0">
-              <a:buNone/>
-            </a:pPr>
-            <a:r>
-              <a:rPr lang="en-US" sz="1400" dirty="0">
-                <a:solidFill>
-                  <a:srgbClr val="5F6368"/>
-                </a:solidFill>
-                <a:latin typeface="Calibri" pitchFamily="34" charset="0"/>
-                <a:ea typeface="Calibri" pitchFamily="34" charset="-122"/>
-                <a:cs typeface="Calibri" pitchFamily="34" charset="-120"/>
-              </a:rPr>
-              <a:t>Drafted this week and put to the group before it is committed to.</a:t>
-            </a:r>
-            <a:endParaRPr lang="en-US" sz="1400" dirty="0"/>
+              <a:t>A proposed question</a:t>
+            </a:r>
           </a:p>
         </p:txBody>
       </p:sp>
@@ -11221,6 +11272,13 @@
           </a:solidFill>
           <a:ln/>
         </p:spPr>
+        <p:txBody>
+          <a:bodyPr/>
+          <a:lstStyle/>
+          <a:p>
+            <a:endParaRPr lang="it-IT"/>
+          </a:p>
+        </p:txBody>
       </p:sp>
       <p:sp>
         <p:nvSpPr>
@@ -11243,7 +11301,7 @@
           <a:bodyPr wrap="square" lIns="0" tIns="0" rIns="0" bIns="0" rtlCol="0" anchor="ctr"/>
           <a:lstStyle/>
           <a:p>
-            <a:pPr indent="0" marL="0">
+            <a:pPr marL="0" indent="0">
               <a:lnSpc>
                 <a:spcPts val="2100"/>
               </a:lnSpc>
@@ -11285,7 +11343,7 @@
           <a:bodyPr wrap="square" lIns="0" tIns="0" rIns="0" bIns="0" rtlCol="0" anchor="ctr"/>
           <a:lstStyle/>
           <a:p>
-            <a:pPr indent="0" marL="0">
+            <a:pPr marL="0" indent="0">
               <a:buNone/>
             </a:pPr>
             <a:r>
@@ -11415,7 +11473,7 @@
           <a:bodyPr wrap="square" lIns="0" tIns="0" rIns="0" bIns="0" rtlCol="0" anchor="ctr"/>
           <a:lstStyle/>
           <a:p>
-            <a:pPr indent="0" marL="0">
+            <a:pPr marL="0" indent="0">
               <a:buNone/>
             </a:pPr>
             <a:r>
@@ -11570,11 +11628,11 @@
           <a:bodyPr wrap="square" lIns="0" tIns="0" rIns="0" bIns="0" rtlCol="0" anchor="ctr"/>
           <a:lstStyle/>
           <a:p>
-            <a:pPr indent="0" marL="0">
+            <a:pPr marL="0" indent="0">
               <a:buNone/>
             </a:pPr>
             <a:r>
-              <a:rPr lang="en-US" sz="1200" b="1" spc="200" kern="0" dirty="0">
+              <a:rPr lang="en-US" sz="1200" b="1" kern="0" spc="200" dirty="0">
                 <a:solidFill>
                   <a:srgbClr val="EB6834"/>
                 </a:solidFill>
@@ -11609,7 +11667,7 @@
           <a:bodyPr wrap="square" lIns="0" tIns="0" rIns="0" bIns="0" rtlCol="0" anchor="ctr"/>
           <a:lstStyle/>
           <a:p>
-            <a:pPr indent="0" marL="0">
+            <a:pPr marL="0" indent="0">
               <a:buNone/>
             </a:pPr>
             <a:r>
@@ -11648,7 +11706,7 @@
           <a:bodyPr wrap="square" lIns="0" tIns="0" rIns="0" bIns="0" rtlCol="0" anchor="ctr"/>
           <a:lstStyle/>
           <a:p>
-            <a:pPr indent="0" marL="0">
+            <a:pPr marL="0" indent="0">
               <a:buNone/>
             </a:pPr>
             <a:r>
@@ -11685,6 +11743,13 @@
           </a:solidFill>
           <a:ln/>
         </p:spPr>
+        <p:txBody>
+          <a:bodyPr/>
+          <a:lstStyle/>
+          <a:p>
+            <a:endParaRPr lang="it-IT"/>
+          </a:p>
+        </p:txBody>
       </p:sp>
       <p:sp>
         <p:nvSpPr>
@@ -11707,7 +11772,7 @@
           <a:bodyPr wrap="square" lIns="0" tIns="0" rIns="0" bIns="0" rtlCol="0" anchor="ctr"/>
           <a:lstStyle/>
           <a:p>
-            <a:pPr algn="ctr" indent="0" marL="0">
+            <a:pPr marL="0" indent="0" algn="ctr">
               <a:buNone/>
             </a:pPr>
             <a:r>
@@ -11746,7 +11811,7 @@
           <a:bodyPr wrap="square" lIns="0" tIns="0" rIns="0" bIns="0" rtlCol="0" anchor="ctr"/>
           <a:lstStyle/>
           <a:p>
-            <a:pPr indent="0" marL="0">
+            <a:pPr marL="0" indent="0">
               <a:buNone/>
             </a:pPr>
             <a:r>
@@ -11785,7 +11850,7 @@
           <a:bodyPr wrap="square" lIns="0" tIns="0" rIns="0" bIns="0" rtlCol="0" anchor="ctr"/>
           <a:lstStyle/>
           <a:p>
-            <a:pPr indent="0" marL="0">
+            <a:pPr marL="0" indent="0">
               <a:lnSpc>
                 <a:spcPts val="1700"/>
               </a:lnSpc>
@@ -11825,6 +11890,13 @@
           </a:solidFill>
           <a:ln/>
         </p:spPr>
+        <p:txBody>
+          <a:bodyPr/>
+          <a:lstStyle/>
+          <a:p>
+            <a:endParaRPr lang="it-IT"/>
+          </a:p>
+        </p:txBody>
       </p:sp>
       <p:sp>
         <p:nvSpPr>
@@ -11847,7 +11919,7 @@
           <a:bodyPr wrap="square" lIns="0" tIns="0" rIns="0" bIns="0" rtlCol="0" anchor="ctr"/>
           <a:lstStyle/>
           <a:p>
-            <a:pPr algn="ctr" indent="0" marL="0">
+            <a:pPr marL="0" indent="0" algn="ctr">
               <a:buNone/>
             </a:pPr>
             <a:r>
@@ -11886,7 +11958,7 @@
           <a:bodyPr wrap="square" lIns="0" tIns="0" rIns="0" bIns="0" rtlCol="0" anchor="ctr"/>
           <a:lstStyle/>
           <a:p>
-            <a:pPr indent="0" marL="0">
+            <a:pPr marL="0" indent="0">
               <a:buNone/>
             </a:pPr>
             <a:r>
@@ -11925,7 +11997,7 @@
           <a:bodyPr wrap="square" lIns="0" tIns="0" rIns="0" bIns="0" rtlCol="0" anchor="ctr"/>
           <a:lstStyle/>
           <a:p>
-            <a:pPr indent="0" marL="0">
+            <a:pPr marL="0" indent="0">
               <a:lnSpc>
                 <a:spcPts val="1700"/>
               </a:lnSpc>
@@ -11965,6 +12037,13 @@
           </a:solidFill>
           <a:ln/>
         </p:spPr>
+        <p:txBody>
+          <a:bodyPr/>
+          <a:lstStyle/>
+          <a:p>
+            <a:endParaRPr lang="it-IT"/>
+          </a:p>
+        </p:txBody>
       </p:sp>
       <p:sp>
         <p:nvSpPr>
@@ -11987,7 +12066,7 @@
           <a:bodyPr wrap="square" lIns="0" tIns="0" rIns="0" bIns="0" rtlCol="0" anchor="ctr"/>
           <a:lstStyle/>
           <a:p>
-            <a:pPr algn="ctr" indent="0" marL="0">
+            <a:pPr marL="0" indent="0" algn="ctr">
               <a:buNone/>
             </a:pPr>
             <a:r>
@@ -12026,7 +12105,7 @@
           <a:bodyPr wrap="square" lIns="0" tIns="0" rIns="0" bIns="0" rtlCol="0" anchor="ctr"/>
           <a:lstStyle/>
           <a:p>
-            <a:pPr indent="0" marL="0">
+            <a:pPr marL="0" indent="0">
               <a:buNone/>
             </a:pPr>
             <a:r>
@@ -12065,7 +12144,7 @@
           <a:bodyPr wrap="square" lIns="0" tIns="0" rIns="0" bIns="0" rtlCol="0" anchor="ctr"/>
           <a:lstStyle/>
           <a:p>
-            <a:pPr indent="0" marL="0">
+            <a:pPr marL="0" indent="0">
               <a:lnSpc>
                 <a:spcPts val="1700"/>
               </a:lnSpc>
@@ -12107,6 +12186,13 @@
           </a:solidFill>
           <a:ln/>
         </p:spPr>
+        <p:txBody>
+          <a:bodyPr/>
+          <a:lstStyle/>
+          <a:p>
+            <a:endParaRPr lang="it-IT"/>
+          </a:p>
+        </p:txBody>
       </p:sp>
       <p:sp>
         <p:nvSpPr>
@@ -12129,7 +12215,7 @@
           <a:bodyPr wrap="square" lIns="0" tIns="0" rIns="0" bIns="0" rtlCol="0" anchor="ctr"/>
           <a:lstStyle/>
           <a:p>
-            <a:pPr indent="0" marL="0">
+            <a:pPr marL="0" indent="0">
               <a:buNone/>
             </a:pPr>
             <a:r>
@@ -12168,7 +12254,7 @@
           <a:bodyPr wrap="square" lIns="0" tIns="0" rIns="0" bIns="0" rtlCol="0" anchor="ctr"/>
           <a:lstStyle/>
           <a:p>
-            <a:pPr indent="0" marL="0">
+            <a:pPr marL="0" indent="0">
               <a:lnSpc>
                 <a:spcPts val="1550"/>
               </a:lnSpc>
@@ -12189,7 +12275,7 @@
             <a:endParaRPr lang="en-US" sz="1150" dirty="0"/>
           </a:p>
           <a:p>
-            <a:pPr indent="0" marL="0">
+            <a:pPr marL="0" indent="0">
               <a:lnSpc>
                 <a:spcPts val="1550"/>
               </a:lnSpc>
@@ -12210,7 +12296,7 @@
             <a:endParaRPr lang="en-US" sz="1150" dirty="0"/>
           </a:p>
           <a:p>
-            <a:pPr indent="0" marL="0">
+            <a:pPr marL="0" indent="0">
               <a:lnSpc>
                 <a:spcPts val="1550"/>
               </a:lnSpc>
@@ -12252,7 +12338,7 @@
           <a:bodyPr wrap="square" lIns="0" tIns="0" rIns="0" bIns="0" rtlCol="0" anchor="ctr"/>
           <a:lstStyle/>
           <a:p>
-            <a:pPr indent="0" marL="0">
+            <a:pPr marL="0" indent="0">
               <a:buNone/>
             </a:pPr>
             <a:r>
@@ -12571,4 +12657,319 @@
     </a:ext>
   </a:extLst>
 </a:theme>
+</file>
+
+<file path=ppt/theme/theme2.xml><?xml version="1.0" encoding="utf-8"?>
+<a:theme xmlns:a="http://schemas.openxmlformats.org/drawingml/2006/main" name="Office Theme">
+  <a:themeElements>
+    <a:clrScheme name="Office">
+      <a:dk1>
+        <a:sysClr val="windowText" lastClr="000000"/>
+      </a:dk1>
+      <a:lt1>
+        <a:sysClr val="window" lastClr="FFFFFF"/>
+      </a:lt1>
+      <a:dk2>
+        <a:srgbClr val="0E2841"/>
+      </a:dk2>
+      <a:lt2>
+        <a:srgbClr val="E8E8E8"/>
+      </a:lt2>
+      <a:accent1>
+        <a:srgbClr val="156082"/>
+      </a:accent1>
+      <a:accent2>
+        <a:srgbClr val="E97132"/>
+      </a:accent2>
+      <a:accent3>
+        <a:srgbClr val="196B24"/>
+      </a:accent3>
+      <a:accent4>
+        <a:srgbClr val="0F9ED5"/>
+      </a:accent4>
+      <a:accent5>
+        <a:srgbClr val="A02B93"/>
+      </a:accent5>
+      <a:accent6>
+        <a:srgbClr val="4EA72E"/>
+      </a:accent6>
+      <a:hlink>
+        <a:srgbClr val="467886"/>
+      </a:hlink>
+      <a:folHlink>
+        <a:srgbClr val="96607D"/>
+      </a:folHlink>
+    </a:clrScheme>
+    <a:fontScheme name="Office">
+      <a:majorFont>
+        <a:latin typeface="Aptos Display" panose="02110004020202020204"/>
+        <a:ea typeface=""/>
+        <a:cs typeface=""/>
+        <a:font script="Jpan" typeface="游ゴシック Light"/>
+        <a:font script="Hang" typeface="맑은 고딕"/>
+        <a:font script="Hans" typeface="等线 Light"/>
+        <a:font script="Hant" typeface="新細明體"/>
+        <a:font script="Arab" typeface="Times New Roman"/>
+        <a:font script="Hebr" typeface="Times New Roman"/>
+        <a:font script="Thai" typeface="Angsana New"/>
+        <a:font script="Ethi" typeface="Nyala"/>
+        <a:font script="Beng" typeface="Vrinda"/>
+        <a:font script="Gujr" typeface="Shruti"/>
+        <a:font script="Khmr" typeface="MoolBoran"/>
+        <a:font script="Knda" typeface="Tunga"/>
+        <a:font script="Guru" typeface="Raavi"/>
+        <a:font script="Cans" typeface="Euphemia"/>
+        <a:font script="Cher" typeface="Plantagenet Cherokee"/>
+        <a:font script="Yiii" typeface="Microsoft Yi Baiti"/>
+        <a:font script="Tibt" typeface="Microsoft Himalaya"/>
+        <a:font script="Thaa" typeface="MV Boli"/>
+        <a:font script="Deva" typeface="Mangal"/>
+        <a:font script="Telu" typeface="Gautami"/>
+        <a:font script="Taml" typeface="Latha"/>
+        <a:font script="Syrc" typeface="Estrangelo Edessa"/>
+        <a:font script="Orya" typeface="Kalinga"/>
+        <a:font script="Mlym" typeface="Kartika"/>
+        <a:font script="Laoo" typeface="DokChampa"/>
+        <a:font script="Sinh" typeface="Iskoola Pota"/>
+        <a:font script="Mong" typeface="Mongolian Baiti"/>
+        <a:font script="Viet" typeface="Times New Roman"/>
+        <a:font script="Uigh" typeface="Microsoft Uighur"/>
+        <a:font script="Geor" typeface="Sylfaen"/>
+        <a:font script="Armn" typeface="Arial"/>
+        <a:font script="Bugi" typeface="Leelawadee UI"/>
+        <a:font script="Bopo" typeface="Microsoft JhengHei"/>
+        <a:font script="Java" typeface="Javanese Text"/>
+        <a:font script="Lisu" typeface="Segoe UI"/>
+        <a:font script="Mymr" typeface="Myanmar Text"/>
+        <a:font script="Nkoo" typeface="Ebrima"/>
+        <a:font script="Olck" typeface="Nirmala UI"/>
+        <a:font script="Osma" typeface="Ebrima"/>
+        <a:font script="Phag" typeface="Phagspa"/>
+        <a:font script="Syrn" typeface="Estrangelo Edessa"/>
+        <a:font script="Syrj" typeface="Estrangelo Edessa"/>
+        <a:font script="Syre" typeface="Estrangelo Edessa"/>
+        <a:font script="Sora" typeface="Nirmala UI"/>
+        <a:font script="Tale" typeface="Microsoft Tai Le"/>
+        <a:font script="Talu" typeface="Microsoft New Tai Lue"/>
+        <a:font script="Tfng" typeface="Ebrima"/>
+      </a:majorFont>
+      <a:minorFont>
+        <a:latin typeface="Aptos" panose="02110004020202020204"/>
+        <a:ea typeface=""/>
+        <a:cs typeface=""/>
+        <a:font script="Jpan" typeface="游ゴシック"/>
+        <a:font script="Hang" typeface="맑은 고딕"/>
+        <a:font script="Hans" typeface="等线"/>
+        <a:font script="Hant" typeface="新細明體"/>
+        <a:font script="Arab" typeface="Arial"/>
+        <a:font script="Hebr" typeface="Arial"/>
+        <a:font script="Thai" typeface="Cordia New"/>
+        <a:font script="Ethi" typeface="Nyala"/>
+        <a:font script="Beng" typeface="Vrinda"/>
+        <a:font script="Gujr" typeface="Shruti"/>
+        <a:font script="Khmr" typeface="DaunPenh"/>
+        <a:font script="Knda" typeface="Tunga"/>
+        <a:font script="Guru" typeface="Raavi"/>
+        <a:font script="Cans" typeface="Euphemia"/>
+        <a:font script="Cher" typeface="Plantagenet Cherokee"/>
+        <a:font script="Yiii" typeface="Microsoft Yi Baiti"/>
+        <a:font script="Tibt" typeface="Microsoft Himalaya"/>
+        <a:font script="Thaa" typeface="MV Boli"/>
+        <a:font script="Deva" typeface="Mangal"/>
+        <a:font script="Telu" typeface="Gautami"/>
+        <a:font script="Taml" typeface="Latha"/>
+        <a:font script="Syrc" typeface="Estrangelo Edessa"/>
+        <a:font script="Orya" typeface="Kalinga"/>
+        <a:font script="Mlym" typeface="Kartika"/>
+        <a:font script="Laoo" typeface="DokChampa"/>
+        <a:font script="Sinh" typeface="Iskoola Pota"/>
+        <a:font script="Mong" typeface="Mongolian Baiti"/>
+        <a:font script="Viet" typeface="Arial"/>
+        <a:font script="Uigh" typeface="Microsoft Uighur"/>
+        <a:font script="Geor" typeface="Sylfaen"/>
+        <a:font script="Armn" typeface="Arial"/>
+        <a:font script="Bugi" typeface="Leelawadee UI"/>
+        <a:font script="Bopo" typeface="Microsoft JhengHei"/>
+        <a:font script="Java" typeface="Javanese Text"/>
+        <a:font script="Lisu" typeface="Segoe UI"/>
+        <a:font script="Mymr" typeface="Myanmar Text"/>
+        <a:font script="Nkoo" typeface="Ebrima"/>
+        <a:font script="Olck" typeface="Nirmala UI"/>
+        <a:font script="Osma" typeface="Ebrima"/>
+        <a:font script="Phag" typeface="Phagspa"/>
+        <a:font script="Syrn" typeface="Estrangelo Edessa"/>
+        <a:font script="Syrj" typeface="Estrangelo Edessa"/>
+        <a:font script="Syre" typeface="Estrangelo Edessa"/>
+        <a:font script="Sora" typeface="Nirmala UI"/>
+        <a:font script="Tale" typeface="Microsoft Tai Le"/>
+        <a:font script="Talu" typeface="Microsoft New Tai Lue"/>
+        <a:font script="Tfng" typeface="Ebrima"/>
+      </a:minorFont>
+    </a:fontScheme>
+    <a:fmtScheme name="Office">
+      <a:fillStyleLst>
+        <a:solidFill>
+          <a:schemeClr val="phClr"/>
+        </a:solidFill>
+        <a:gradFill rotWithShape="1">
+          <a:gsLst>
+            <a:gs pos="0">
+              <a:schemeClr val="phClr">
+                <a:lumMod val="110000"/>
+                <a:satMod val="105000"/>
+                <a:tint val="67000"/>
+              </a:schemeClr>
+            </a:gs>
+            <a:gs pos="50000">
+              <a:schemeClr val="phClr">
+                <a:lumMod val="105000"/>
+                <a:satMod val="103000"/>
+                <a:tint val="73000"/>
+              </a:schemeClr>
+            </a:gs>
+            <a:gs pos="100000">
+              <a:schemeClr val="phClr">
+                <a:lumMod val="105000"/>
+                <a:satMod val="109000"/>
+                <a:tint val="81000"/>
+              </a:schemeClr>
+            </a:gs>
+          </a:gsLst>
+          <a:lin ang="5400000" scaled="0"/>
+        </a:gradFill>
+        <a:gradFill rotWithShape="1">
+          <a:gsLst>
+            <a:gs pos="0">
+              <a:schemeClr val="phClr">
+                <a:satMod val="103000"/>
+                <a:lumMod val="102000"/>
+                <a:tint val="94000"/>
+              </a:schemeClr>
+            </a:gs>
+            <a:gs pos="50000">
+              <a:schemeClr val="phClr">
+                <a:satMod val="110000"/>
+                <a:lumMod val="100000"/>
+                <a:shade val="100000"/>
+              </a:schemeClr>
+            </a:gs>
+            <a:gs pos="100000">
+              <a:schemeClr val="phClr">
+                <a:lumMod val="99000"/>
+                <a:satMod val="120000"/>
+                <a:shade val="78000"/>
+              </a:schemeClr>
+            </a:gs>
+          </a:gsLst>
+          <a:lin ang="5400000" scaled="0"/>
+        </a:gradFill>
+      </a:fillStyleLst>
+      <a:lnStyleLst>
+        <a:ln w="12700" cap="flat" cmpd="sng" algn="ctr">
+          <a:solidFill>
+            <a:schemeClr val="phClr"/>
+          </a:solidFill>
+          <a:prstDash val="solid"/>
+          <a:miter lim="800000"/>
+        </a:ln>
+        <a:ln w="19050" cap="flat" cmpd="sng" algn="ctr">
+          <a:solidFill>
+            <a:schemeClr val="phClr"/>
+          </a:solidFill>
+          <a:prstDash val="solid"/>
+          <a:miter lim="800000"/>
+        </a:ln>
+        <a:ln w="25400" cap="flat" cmpd="sng" algn="ctr">
+          <a:solidFill>
+            <a:schemeClr val="phClr"/>
+          </a:solidFill>
+          <a:prstDash val="solid"/>
+          <a:miter lim="800000"/>
+        </a:ln>
+      </a:lnStyleLst>
+      <a:effectStyleLst>
+        <a:effectStyle>
+          <a:effectLst/>
+        </a:effectStyle>
+        <a:effectStyle>
+          <a:effectLst/>
+        </a:effectStyle>
+        <a:effectStyle>
+          <a:effectLst>
+            <a:outerShdw blurRad="57150" dist="19050" dir="5400000" algn="ctr" rotWithShape="0">
+              <a:srgbClr val="000000">
+                <a:alpha val="63000"/>
+              </a:srgbClr>
+            </a:outerShdw>
+          </a:effectLst>
+        </a:effectStyle>
+      </a:effectStyleLst>
+      <a:bgFillStyleLst>
+        <a:solidFill>
+          <a:schemeClr val="phClr"/>
+        </a:solidFill>
+        <a:solidFill>
+          <a:schemeClr val="phClr">
+            <a:tint val="95000"/>
+            <a:satMod val="170000"/>
+          </a:schemeClr>
+        </a:solidFill>
+        <a:gradFill rotWithShape="1">
+          <a:gsLst>
+            <a:gs pos="0">
+              <a:schemeClr val="phClr">
+                <a:tint val="93000"/>
+                <a:satMod val="150000"/>
+                <a:shade val="98000"/>
+                <a:lumMod val="102000"/>
+              </a:schemeClr>
+            </a:gs>
+            <a:gs pos="50000">
+              <a:schemeClr val="phClr">
+                <a:tint val="98000"/>
+                <a:satMod val="130000"/>
+                <a:shade val="90000"/>
+                <a:lumMod val="103000"/>
+              </a:schemeClr>
+            </a:gs>
+            <a:gs pos="100000">
+              <a:schemeClr val="phClr">
+                <a:shade val="63000"/>
+                <a:satMod val="120000"/>
+              </a:schemeClr>
+            </a:gs>
+          </a:gsLst>
+          <a:lin ang="5400000" scaled="0"/>
+        </a:gradFill>
+      </a:bgFillStyleLst>
+    </a:fmtScheme>
+  </a:themeElements>
+  <a:objectDefaults>
+    <a:lnDef>
+      <a:spPr/>
+      <a:bodyPr/>
+      <a:lstStyle/>
+      <a:style>
+        <a:lnRef idx="2">
+          <a:schemeClr val="accent1"/>
+        </a:lnRef>
+        <a:fillRef idx="0">
+          <a:schemeClr val="accent1"/>
+        </a:fillRef>
+        <a:effectRef idx="1">
+          <a:schemeClr val="accent1"/>
+        </a:effectRef>
+        <a:fontRef idx="minor">
+          <a:schemeClr val="tx1"/>
+        </a:fontRef>
+      </a:style>
+    </a:lnDef>
+  </a:objectDefaults>
+  <a:extraClrSchemeLst/>
+  <a:extLst>
+    <a:ext uri="{05A4C25C-085E-4340-85A3-A5531E510DB2}">
+      <thm15:themeFamily xmlns:thm15="http://schemas.microsoft.com/office/thememl/2012/main" name="Office Theme" id="{2E142A2C-CD16-42D6-873A-C26D2A0506FA}" vid="{1BDDFF52-6CD6-40A5-AB3C-68EB2F1E4D0A}"/>
+    </a:ext>
+  </a:extLst>
+</a:theme>
 </file>
</xml_diff>